<commit_message>
VIP deck: enlarge body text and remove footer text
- Bump body/paragraph, bullet and card font sizes across slides for readability
- Remove the footer label (no-op add_footer) to clear the footer area
</commit_message>
<xml_diff>
--- a/wla-vip-121-deck.pptx
+++ b/wla-vip-121-deck.pptx
@@ -3394,7 +3394,7 @@
               </a:lnSpc>
             </a:pPr>
             <a:r>
-              <a:rPr sz="1900" b="0" i="1">
+              <a:rPr sz="2000" b="0" i="1">
                 <a:solidFill>
                   <a:srgbClr val="5A6478"/>
                 </a:solidFill>
@@ -3677,7 +3677,7 @@
               </a:spcAft>
             </a:pPr>
             <a:r>
-              <a:rPr sz="1900" b="0" i="0">
+              <a:rPr sz="2100" b="0" i="0">
                 <a:solidFill>
                   <a:srgbClr val="F4EBDC"/>
                 </a:solidFill>
@@ -3700,84 +3700,6 @@
                 <a:latin typeface="Libre Baskerville"/>
               </a:rPr>
               <a:t>It’s not the plan. It’s the support, accountability and feedback.</a:t>
-            </a:r>
-          </a:p>
-        </p:txBody>
-      </p:sp>
-      <p:sp>
-        <p:nvSpPr>
-          <p:cNvPr id="7" name="TextBox 6"/>
-          <p:cNvSpPr txBox="1"/>
-          <p:nvPr/>
-        </p:nvSpPr>
-        <p:spPr>
-          <a:xfrm>
-            <a:off x="640080" y="6382512"/>
-            <a:ext cx="7315200" cy="365760"/>
-          </a:xfrm>
-          <a:prstGeom prst="rect">
-            <a:avLst/>
-          </a:prstGeom>
-          <a:noFill/>
-        </p:spPr>
-        <p:txBody>
-          <a:bodyPr wrap="square" lIns="0" rIns="0" tIns="0" bIns="0" anchor="t">
-            <a:spAutoFit/>
-          </a:bodyPr>
-          <a:lstStyle/>
-          <a:p>
-            <a:pPr algn="l">
-              <a:lnSpc>
-                <a:spcPct val="120000"/>
-              </a:lnSpc>
-            </a:pPr>
-            <a:r>
-              <a:rPr sz="1250" b="0" i="1">
-                <a:solidFill>
-                  <a:srgbClr val="F4EBDC"/>
-                </a:solidFill>
-                <a:latin typeface="Libre Baskerville"/>
-              </a:rPr>
-              <a:t>The Weight Loss Academy</a:t>
-            </a:r>
-          </a:p>
-        </p:txBody>
-      </p:sp>
-      <p:sp>
-        <p:nvSpPr>
-          <p:cNvPr id="8" name="TextBox 7"/>
-          <p:cNvSpPr txBox="1"/>
-          <p:nvPr/>
-        </p:nvSpPr>
-        <p:spPr>
-          <a:xfrm>
-            <a:off x="6949440" y="6382512"/>
-            <a:ext cx="4572000" cy="365760"/>
-          </a:xfrm>
-          <a:prstGeom prst="rect">
-            <a:avLst/>
-          </a:prstGeom>
-          <a:noFill/>
-        </p:spPr>
-        <p:txBody>
-          <a:bodyPr wrap="square" lIns="0" rIns="0" tIns="0" bIns="0" anchor="t">
-            <a:spAutoFit/>
-          </a:bodyPr>
-          <a:lstStyle/>
-          <a:p>
-            <a:pPr algn="r">
-              <a:lnSpc>
-                <a:spcPct val="120000"/>
-              </a:lnSpc>
-            </a:pPr>
-            <a:r>
-              <a:rPr sz="1100" b="1" i="0" spc="200">
-                <a:solidFill>
-                  <a:srgbClr val="F4EBDC"/>
-                </a:solidFill>
-                <a:latin typeface="Alegreya Sans"/>
-              </a:rPr>
-              <a:t>VIP 1-2-1 PERSONAL COACHING</a:t>
             </a:r>
           </a:p>
         </p:txBody>
@@ -4006,7 +3928,7 @@
               </a:spcAft>
             </a:pPr>
             <a:r>
-              <a:rPr sz="1900" b="0" i="0">
+              <a:rPr sz="2100" b="0" i="0">
                 <a:solidFill>
                   <a:srgbClr val="333333"/>
                 </a:solidFill>
@@ -4029,84 +3951,6 @@
                 <a:latin typeface="Libre Baskerville"/>
               </a:rPr>
               <a:t>Not because they don’t care — because they’re trying to do it alone. That’s exactly why VIP works.</a:t>
-            </a:r>
-          </a:p>
-        </p:txBody>
-      </p:sp>
-      <p:sp>
-        <p:nvSpPr>
-          <p:cNvPr id="7" name="TextBox 6"/>
-          <p:cNvSpPr txBox="1"/>
-          <p:nvPr/>
-        </p:nvSpPr>
-        <p:spPr>
-          <a:xfrm>
-            <a:off x="640080" y="6382512"/>
-            <a:ext cx="7315200" cy="365760"/>
-          </a:xfrm>
-          <a:prstGeom prst="rect">
-            <a:avLst/>
-          </a:prstGeom>
-          <a:noFill/>
-        </p:spPr>
-        <p:txBody>
-          <a:bodyPr wrap="square" lIns="0" rIns="0" tIns="0" bIns="0" anchor="t">
-            <a:spAutoFit/>
-          </a:bodyPr>
-          <a:lstStyle/>
-          <a:p>
-            <a:pPr algn="l">
-              <a:lnSpc>
-                <a:spcPct val="120000"/>
-              </a:lnSpc>
-            </a:pPr>
-            <a:r>
-              <a:rPr sz="1250" b="0" i="1">
-                <a:solidFill>
-                  <a:srgbClr val="5A6478"/>
-                </a:solidFill>
-                <a:latin typeface="Libre Baskerville"/>
-              </a:rPr>
-              <a:t>The Weight Loss Academy</a:t>
-            </a:r>
-          </a:p>
-        </p:txBody>
-      </p:sp>
-      <p:sp>
-        <p:nvSpPr>
-          <p:cNvPr id="8" name="TextBox 7"/>
-          <p:cNvSpPr txBox="1"/>
-          <p:nvPr/>
-        </p:nvSpPr>
-        <p:spPr>
-          <a:xfrm>
-            <a:off x="6949440" y="6382512"/>
-            <a:ext cx="4572000" cy="365760"/>
-          </a:xfrm>
-          <a:prstGeom prst="rect">
-            <a:avLst/>
-          </a:prstGeom>
-          <a:noFill/>
-        </p:spPr>
-        <p:txBody>
-          <a:bodyPr wrap="square" lIns="0" rIns="0" tIns="0" bIns="0" anchor="t">
-            <a:spAutoFit/>
-          </a:bodyPr>
-          <a:lstStyle/>
-          <a:p>
-            <a:pPr algn="r">
-              <a:lnSpc>
-                <a:spcPct val="120000"/>
-              </a:lnSpc>
-            </a:pPr>
-            <a:r>
-              <a:rPr sz="1100" b="1" i="0" spc="200">
-                <a:solidFill>
-                  <a:srgbClr val="5A6478"/>
-                </a:solidFill>
-                <a:latin typeface="Alegreya Sans"/>
-              </a:rPr>
-              <a:t>VIP 1-2-1 PERSONAL COACHING</a:t>
             </a:r>
           </a:p>
         </p:txBody>
@@ -4321,7 +4165,7 @@
         </p:nvSpPr>
         <p:spPr>
           <a:xfrm>
-            <a:off x="868680" y="3157537"/>
+            <a:off x="868680" y="3171825"/>
             <a:ext cx="118872" cy="118872"/>
           </a:xfrm>
           <a:prstGeom prst="ellipse">
@@ -4385,7 +4229,7 @@
               </a:lnSpc>
             </a:pPr>
             <a:r>
-              <a:rPr sz="1650" b="0" i="0">
+              <a:rPr sz="1900" b="0" i="0">
                 <a:solidFill>
                   <a:srgbClr val="333333"/>
                 </a:solidFill>
@@ -4404,7 +4248,7 @@
         </p:nvSpPr>
         <p:spPr>
           <a:xfrm>
-            <a:off x="6263640" y="3157537"/>
+            <a:off x="6263640" y="3171825"/>
             <a:ext cx="118872" cy="118872"/>
           </a:xfrm>
           <a:prstGeom prst="ellipse">
@@ -4468,7 +4312,7 @@
               </a:lnSpc>
             </a:pPr>
             <a:r>
-              <a:rPr sz="1650" b="0" i="0">
+              <a:rPr sz="1900" b="0" i="0">
                 <a:solidFill>
                   <a:srgbClr val="333333"/>
                 </a:solidFill>
@@ -4487,7 +4331,7 @@
         </p:nvSpPr>
         <p:spPr>
           <a:xfrm>
-            <a:off x="868680" y="3907345"/>
+            <a:off x="868680" y="3921633"/>
             <a:ext cx="118872" cy="118872"/>
           </a:xfrm>
           <a:prstGeom prst="ellipse">
@@ -4551,7 +4395,7 @@
               </a:lnSpc>
             </a:pPr>
             <a:r>
-              <a:rPr sz="1650" b="0" i="0">
+              <a:rPr sz="1900" b="0" i="0">
                 <a:solidFill>
                   <a:srgbClr val="333333"/>
                 </a:solidFill>
@@ -4570,7 +4414,7 @@
         </p:nvSpPr>
         <p:spPr>
           <a:xfrm>
-            <a:off x="6263640" y="3907345"/>
+            <a:off x="6263640" y="3921633"/>
             <a:ext cx="118872" cy="118872"/>
           </a:xfrm>
           <a:prstGeom prst="ellipse">
@@ -4634,7 +4478,7 @@
               </a:lnSpc>
             </a:pPr>
             <a:r>
-              <a:rPr sz="1650" b="0" i="0">
+              <a:rPr sz="1900" b="0" i="0">
                 <a:solidFill>
                   <a:srgbClr val="333333"/>
                 </a:solidFill>
@@ -4653,7 +4497,7 @@
         </p:nvSpPr>
         <p:spPr>
           <a:xfrm>
-            <a:off x="868680" y="4657153"/>
+            <a:off x="868680" y="4671441"/>
             <a:ext cx="118872" cy="118872"/>
           </a:xfrm>
           <a:prstGeom prst="ellipse">
@@ -4717,7 +4561,7 @@
               </a:lnSpc>
             </a:pPr>
             <a:r>
-              <a:rPr sz="1650" b="0" i="0">
+              <a:rPr sz="1900" b="0" i="0">
                 <a:solidFill>
                   <a:srgbClr val="333333"/>
                 </a:solidFill>
@@ -4736,7 +4580,7 @@
         </p:nvSpPr>
         <p:spPr>
           <a:xfrm>
-            <a:off x="6263640" y="4657153"/>
+            <a:off x="6263640" y="4671441"/>
             <a:ext cx="118872" cy="118872"/>
           </a:xfrm>
           <a:prstGeom prst="ellipse">
@@ -4800,91 +4644,13 @@
               </a:lnSpc>
             </a:pPr>
             <a:r>
-              <a:rPr sz="1650" b="0" i="0">
+              <a:rPr sz="1900" b="0" i="0">
                 <a:solidFill>
                   <a:srgbClr val="333333"/>
                 </a:solidFill>
                 <a:latin typeface="Alegreya Sans"/>
               </a:rPr>
               <a:t>Knowing exactly how to eat to lose weight and keep it off</a:t>
-            </a:r>
-          </a:p>
-        </p:txBody>
-      </p:sp>
-      <p:sp>
-        <p:nvSpPr>
-          <p:cNvPr id="18" name="TextBox 17"/>
-          <p:cNvSpPr txBox="1"/>
-          <p:nvPr/>
-        </p:nvSpPr>
-        <p:spPr>
-          <a:xfrm>
-            <a:off x="640080" y="6382512"/>
-            <a:ext cx="7315200" cy="365760"/>
-          </a:xfrm>
-          <a:prstGeom prst="rect">
-            <a:avLst/>
-          </a:prstGeom>
-          <a:noFill/>
-        </p:spPr>
-        <p:txBody>
-          <a:bodyPr wrap="square" lIns="0" rIns="0" tIns="0" bIns="0" anchor="t">
-            <a:spAutoFit/>
-          </a:bodyPr>
-          <a:lstStyle/>
-          <a:p>
-            <a:pPr algn="l">
-              <a:lnSpc>
-                <a:spcPct val="120000"/>
-              </a:lnSpc>
-            </a:pPr>
-            <a:r>
-              <a:rPr sz="1250" b="0" i="1">
-                <a:solidFill>
-                  <a:srgbClr val="5A6478"/>
-                </a:solidFill>
-                <a:latin typeface="Libre Baskerville"/>
-              </a:rPr>
-              <a:t>The Weight Loss Academy</a:t>
-            </a:r>
-          </a:p>
-        </p:txBody>
-      </p:sp>
-      <p:sp>
-        <p:nvSpPr>
-          <p:cNvPr id="19" name="TextBox 18"/>
-          <p:cNvSpPr txBox="1"/>
-          <p:nvPr/>
-        </p:nvSpPr>
-        <p:spPr>
-          <a:xfrm>
-            <a:off x="6949440" y="6382512"/>
-            <a:ext cx="4572000" cy="365760"/>
-          </a:xfrm>
-          <a:prstGeom prst="rect">
-            <a:avLst/>
-          </a:prstGeom>
-          <a:noFill/>
-        </p:spPr>
-        <p:txBody>
-          <a:bodyPr wrap="square" lIns="0" rIns="0" tIns="0" bIns="0" anchor="t">
-            <a:spAutoFit/>
-          </a:bodyPr>
-          <a:lstStyle/>
-          <a:p>
-            <a:pPr algn="r">
-              <a:lnSpc>
-                <a:spcPct val="120000"/>
-              </a:lnSpc>
-            </a:pPr>
-            <a:r>
-              <a:rPr sz="1100" b="1" i="0" spc="200">
-                <a:solidFill>
-                  <a:srgbClr val="5A6478"/>
-                </a:solidFill>
-                <a:latin typeface="Alegreya Sans"/>
-              </a:rPr>
-              <a:t>VIP 1-2-1 PERSONAL COACHING</a:t>
             </a:r>
           </a:p>
         </p:txBody>
@@ -5167,7 +4933,7 @@
               </a:lnSpc>
             </a:pPr>
             <a:r>
-              <a:rPr sz="1300" b="1" i="0" spc="150">
+              <a:rPr sz="1400" b="1" i="0" spc="150">
                 <a:solidFill>
                   <a:srgbClr val="D97757"/>
                 </a:solidFill>
@@ -5206,7 +4972,7 @@
               </a:lnSpc>
             </a:pPr>
             <a:r>
-              <a:rPr sz="1350" b="0" i="0">
+              <a:rPr sz="1500" b="0" i="0">
                 <a:solidFill>
                   <a:srgbClr val="333333"/>
                 </a:solidFill>
@@ -5293,7 +5059,7 @@
               </a:lnSpc>
             </a:pPr>
             <a:r>
-              <a:rPr sz="1300" b="1" i="0" spc="150">
+              <a:rPr sz="1400" b="1" i="0" spc="150">
                 <a:solidFill>
                   <a:srgbClr val="D97757"/>
                 </a:solidFill>
@@ -5332,7 +5098,7 @@
               </a:lnSpc>
             </a:pPr>
             <a:r>
-              <a:rPr sz="1350" b="0" i="0">
+              <a:rPr sz="1500" b="0" i="0">
                 <a:solidFill>
                   <a:srgbClr val="333333"/>
                 </a:solidFill>
@@ -5419,7 +5185,7 @@
               </a:lnSpc>
             </a:pPr>
             <a:r>
-              <a:rPr sz="1300" b="1" i="0" spc="150">
+              <a:rPr sz="1400" b="1" i="0" spc="150">
                 <a:solidFill>
                   <a:srgbClr val="D97757"/>
                 </a:solidFill>
@@ -5458,7 +5224,7 @@
               </a:lnSpc>
             </a:pPr>
             <a:r>
-              <a:rPr sz="1350" b="0" i="0">
+              <a:rPr sz="1500" b="0" i="0">
                 <a:solidFill>
                   <a:srgbClr val="333333"/>
                 </a:solidFill>
@@ -5545,7 +5311,7 @@
               </a:lnSpc>
             </a:pPr>
             <a:r>
-              <a:rPr sz="1300" b="1" i="0" spc="150">
+              <a:rPr sz="1400" b="1" i="0" spc="150">
                 <a:solidFill>
                   <a:srgbClr val="D97757"/>
                 </a:solidFill>
@@ -5584,7 +5350,7 @@
               </a:lnSpc>
             </a:pPr>
             <a:r>
-              <a:rPr sz="1350" b="0" i="0">
+              <a:rPr sz="1500" b="0" i="0">
                 <a:solidFill>
                   <a:srgbClr val="333333"/>
                 </a:solidFill>
@@ -5671,7 +5437,7 @@
               </a:lnSpc>
             </a:pPr>
             <a:r>
-              <a:rPr sz="1300" b="1" i="0" spc="150">
+              <a:rPr sz="1400" b="1" i="0" spc="150">
                 <a:solidFill>
                   <a:srgbClr val="D97757"/>
                 </a:solidFill>
@@ -5710,7 +5476,7 @@
               </a:lnSpc>
             </a:pPr>
             <a:r>
-              <a:rPr sz="1350" b="0" i="0">
+              <a:rPr sz="1500" b="0" i="0">
                 <a:solidFill>
                   <a:srgbClr val="333333"/>
                 </a:solidFill>
@@ -5797,7 +5563,7 @@
               </a:lnSpc>
             </a:pPr>
             <a:r>
-              <a:rPr sz="1300" b="1" i="0" spc="150">
+              <a:rPr sz="1400" b="1" i="0" spc="150">
                 <a:solidFill>
                   <a:srgbClr val="D97757"/>
                 </a:solidFill>
@@ -5836,91 +5602,13 @@
               </a:lnSpc>
             </a:pPr>
             <a:r>
-              <a:rPr sz="1350" b="0" i="0">
+              <a:rPr sz="1500" b="0" i="0">
                 <a:solidFill>
                   <a:srgbClr val="333333"/>
                 </a:solidFill>
                 <a:latin typeface="Alegreya Sans"/>
               </a:rPr>
               <a:t>Want weekend handholding so you don’t undo your hard work?</a:t>
-            </a:r>
-          </a:p>
-        </p:txBody>
-      </p:sp>
-      <p:sp>
-        <p:nvSpPr>
-          <p:cNvPr id="24" name="TextBox 23"/>
-          <p:cNvSpPr txBox="1"/>
-          <p:nvPr/>
-        </p:nvSpPr>
-        <p:spPr>
-          <a:xfrm>
-            <a:off x="640080" y="6382512"/>
-            <a:ext cx="7315200" cy="365760"/>
-          </a:xfrm>
-          <a:prstGeom prst="rect">
-            <a:avLst/>
-          </a:prstGeom>
-          <a:noFill/>
-        </p:spPr>
-        <p:txBody>
-          <a:bodyPr wrap="square" lIns="0" rIns="0" tIns="0" bIns="0" anchor="t">
-            <a:spAutoFit/>
-          </a:bodyPr>
-          <a:lstStyle/>
-          <a:p>
-            <a:pPr algn="l">
-              <a:lnSpc>
-                <a:spcPct val="120000"/>
-              </a:lnSpc>
-            </a:pPr>
-            <a:r>
-              <a:rPr sz="1250" b="0" i="1">
-                <a:solidFill>
-                  <a:srgbClr val="5A6478"/>
-                </a:solidFill>
-                <a:latin typeface="Libre Baskerville"/>
-              </a:rPr>
-              <a:t>The Weight Loss Academy</a:t>
-            </a:r>
-          </a:p>
-        </p:txBody>
-      </p:sp>
-      <p:sp>
-        <p:nvSpPr>
-          <p:cNvPr id="25" name="TextBox 24"/>
-          <p:cNvSpPr txBox="1"/>
-          <p:nvPr/>
-        </p:nvSpPr>
-        <p:spPr>
-          <a:xfrm>
-            <a:off x="6949440" y="6382512"/>
-            <a:ext cx="4572000" cy="365760"/>
-          </a:xfrm>
-          <a:prstGeom prst="rect">
-            <a:avLst/>
-          </a:prstGeom>
-          <a:noFill/>
-        </p:spPr>
-        <p:txBody>
-          <a:bodyPr wrap="square" lIns="0" rIns="0" tIns="0" bIns="0" anchor="t">
-            <a:spAutoFit/>
-          </a:bodyPr>
-          <a:lstStyle/>
-          <a:p>
-            <a:pPr algn="r">
-              <a:lnSpc>
-                <a:spcPct val="120000"/>
-              </a:lnSpc>
-            </a:pPr>
-            <a:r>
-              <a:rPr sz="1100" b="1" i="0" spc="200">
-                <a:solidFill>
-                  <a:srgbClr val="5A6478"/>
-                </a:solidFill>
-                <a:latin typeface="Alegreya Sans"/>
-              </a:rPr>
-              <a:t>VIP 1-2-1 PERSONAL COACHING</a:t>
             </a:r>
           </a:p>
         </p:txBody>
@@ -6203,91 +5891,13 @@
               </a:lnSpc>
             </a:pPr>
             <a:r>
-              <a:rPr sz="1800" b="0" i="1">
+              <a:rPr sz="2000" b="0" i="1">
                 <a:solidFill>
                   <a:srgbClr val="5A6478"/>
                 </a:solidFill>
                 <a:latin typeface="Libre Baskerville"/>
               </a:rPr>
               <a:t>“VIP has changed my life. I did WLA resets and group for 2 years and didn’t achieve half of what I have in VIP. It’s just so different.”</a:t>
-            </a:r>
-          </a:p>
-        </p:txBody>
-      </p:sp>
-      <p:sp>
-        <p:nvSpPr>
-          <p:cNvPr id="8" name="TextBox 7"/>
-          <p:cNvSpPr txBox="1"/>
-          <p:nvPr/>
-        </p:nvSpPr>
-        <p:spPr>
-          <a:xfrm>
-            <a:off x="640080" y="6382512"/>
-            <a:ext cx="7315200" cy="365760"/>
-          </a:xfrm>
-          <a:prstGeom prst="rect">
-            <a:avLst/>
-          </a:prstGeom>
-          <a:noFill/>
-        </p:spPr>
-        <p:txBody>
-          <a:bodyPr wrap="square" lIns="0" rIns="0" tIns="0" bIns="0" anchor="t">
-            <a:spAutoFit/>
-          </a:bodyPr>
-          <a:lstStyle/>
-          <a:p>
-            <a:pPr algn="l">
-              <a:lnSpc>
-                <a:spcPct val="120000"/>
-              </a:lnSpc>
-            </a:pPr>
-            <a:r>
-              <a:rPr sz="1250" b="0" i="1">
-                <a:solidFill>
-                  <a:srgbClr val="5A6478"/>
-                </a:solidFill>
-                <a:latin typeface="Libre Baskerville"/>
-              </a:rPr>
-              <a:t>The Weight Loss Academy</a:t>
-            </a:r>
-          </a:p>
-        </p:txBody>
-      </p:sp>
-      <p:sp>
-        <p:nvSpPr>
-          <p:cNvPr id="9" name="TextBox 8"/>
-          <p:cNvSpPr txBox="1"/>
-          <p:nvPr/>
-        </p:nvSpPr>
-        <p:spPr>
-          <a:xfrm>
-            <a:off x="6949440" y="6382512"/>
-            <a:ext cx="4572000" cy="365760"/>
-          </a:xfrm>
-          <a:prstGeom prst="rect">
-            <a:avLst/>
-          </a:prstGeom>
-          <a:noFill/>
-        </p:spPr>
-        <p:txBody>
-          <a:bodyPr wrap="square" lIns="0" rIns="0" tIns="0" bIns="0" anchor="t">
-            <a:spAutoFit/>
-          </a:bodyPr>
-          <a:lstStyle/>
-          <a:p>
-            <a:pPr algn="r">
-              <a:lnSpc>
-                <a:spcPct val="120000"/>
-              </a:lnSpc>
-            </a:pPr>
-            <a:r>
-              <a:rPr sz="1100" b="1" i="0" spc="200">
-                <a:solidFill>
-                  <a:srgbClr val="5A6478"/>
-                </a:solidFill>
-                <a:latin typeface="Alegreya Sans"/>
-              </a:rPr>
-              <a:t>VIP 1-2-1 PERSONAL COACHING</a:t>
             </a:r>
           </a:p>
         </p:txBody>
@@ -6622,91 +6232,13 @@
               </a:lnSpc>
             </a:pPr>
             <a:r>
-              <a:rPr sz="1700" b="0" i="1">
+              <a:rPr sz="1900" b="0" i="1">
                 <a:solidFill>
                   <a:srgbClr val="F4EBDC"/>
                 </a:solidFill>
                 <a:latin typeface="Libre Baskerville"/>
               </a:rPr>
               <a:t>From 1 to 4 stone down — in 1-2-1 VIP coaching with Anna.</a:t>
-            </a:r>
-          </a:p>
-        </p:txBody>
-      </p:sp>
-      <p:sp>
-        <p:nvSpPr>
-          <p:cNvPr id="11" name="TextBox 10"/>
-          <p:cNvSpPr txBox="1"/>
-          <p:nvPr/>
-        </p:nvSpPr>
-        <p:spPr>
-          <a:xfrm>
-            <a:off x="640080" y="6382512"/>
-            <a:ext cx="7315200" cy="365760"/>
-          </a:xfrm>
-          <a:prstGeom prst="rect">
-            <a:avLst/>
-          </a:prstGeom>
-          <a:noFill/>
-        </p:spPr>
-        <p:txBody>
-          <a:bodyPr wrap="square" lIns="0" rIns="0" tIns="0" bIns="0" anchor="t">
-            <a:spAutoFit/>
-          </a:bodyPr>
-          <a:lstStyle/>
-          <a:p>
-            <a:pPr algn="l">
-              <a:lnSpc>
-                <a:spcPct val="120000"/>
-              </a:lnSpc>
-            </a:pPr>
-            <a:r>
-              <a:rPr sz="1250" b="0" i="1">
-                <a:solidFill>
-                  <a:srgbClr val="F4EBDC"/>
-                </a:solidFill>
-                <a:latin typeface="Libre Baskerville"/>
-              </a:rPr>
-              <a:t>The Weight Loss Academy</a:t>
-            </a:r>
-          </a:p>
-        </p:txBody>
-      </p:sp>
-      <p:sp>
-        <p:nvSpPr>
-          <p:cNvPr id="12" name="TextBox 11"/>
-          <p:cNvSpPr txBox="1"/>
-          <p:nvPr/>
-        </p:nvSpPr>
-        <p:spPr>
-          <a:xfrm>
-            <a:off x="6949440" y="6382512"/>
-            <a:ext cx="4572000" cy="365760"/>
-          </a:xfrm>
-          <a:prstGeom prst="rect">
-            <a:avLst/>
-          </a:prstGeom>
-          <a:noFill/>
-        </p:spPr>
-        <p:txBody>
-          <a:bodyPr wrap="square" lIns="0" rIns="0" tIns="0" bIns="0" anchor="t">
-            <a:spAutoFit/>
-          </a:bodyPr>
-          <a:lstStyle/>
-          <a:p>
-            <a:pPr algn="r">
-              <a:lnSpc>
-                <a:spcPct val="120000"/>
-              </a:lnSpc>
-            </a:pPr>
-            <a:r>
-              <a:rPr sz="1100" b="1" i="0" spc="200">
-                <a:solidFill>
-                  <a:srgbClr val="F4EBDC"/>
-                </a:solidFill>
-                <a:latin typeface="Alegreya Sans"/>
-              </a:rPr>
-              <a:t>VIP 1-2-1 PERSONAL COACHING</a:t>
             </a:r>
           </a:p>
         </p:txBody>
@@ -6988,7 +6520,7 @@
               </a:spcAft>
             </a:pPr>
             <a:r>
-              <a:rPr sz="1600" b="1" i="0">
+              <a:rPr sz="1800" b="1" i="0">
                 <a:solidFill>
                   <a:srgbClr val="0E2746"/>
                 </a:solidFill>
@@ -7004,7 +6536,7 @@
               </a:lnSpc>
             </a:pPr>
             <a:r>
-              <a:rPr sz="1300" b="0" i="0">
+              <a:rPr sz="1500" b="0" i="0">
                 <a:solidFill>
                   <a:srgbClr val="5A6478"/>
                 </a:solidFill>
@@ -7099,7 +6631,7 @@
               </a:spcAft>
             </a:pPr>
             <a:r>
-              <a:rPr sz="1600" b="1" i="0">
+              <a:rPr sz="1800" b="1" i="0">
                 <a:solidFill>
                   <a:srgbClr val="0E2746"/>
                 </a:solidFill>
@@ -7115,7 +6647,7 @@
               </a:lnSpc>
             </a:pPr>
             <a:r>
-              <a:rPr sz="1300" b="0" i="0">
+              <a:rPr sz="1500" b="0" i="0">
                 <a:solidFill>
                   <a:srgbClr val="5A6478"/>
                 </a:solidFill>
@@ -7210,7 +6742,7 @@
               </a:spcAft>
             </a:pPr>
             <a:r>
-              <a:rPr sz="1600" b="1" i="0">
+              <a:rPr sz="1800" b="1" i="0">
                 <a:solidFill>
                   <a:srgbClr val="0E2746"/>
                 </a:solidFill>
@@ -7226,7 +6758,7 @@
               </a:lnSpc>
             </a:pPr>
             <a:r>
-              <a:rPr sz="1300" b="0" i="0">
+              <a:rPr sz="1500" b="0" i="0">
                 <a:solidFill>
                   <a:srgbClr val="5A6478"/>
                 </a:solidFill>
@@ -7321,7 +6853,7 @@
               </a:spcAft>
             </a:pPr>
             <a:r>
-              <a:rPr sz="1600" b="1" i="0">
+              <a:rPr sz="1800" b="1" i="0">
                 <a:solidFill>
                   <a:srgbClr val="0E2746"/>
                 </a:solidFill>
@@ -7337,7 +6869,7 @@
               </a:lnSpc>
             </a:pPr>
             <a:r>
-              <a:rPr sz="1300" b="0" i="0">
+              <a:rPr sz="1500" b="0" i="0">
                 <a:solidFill>
                   <a:srgbClr val="5A6478"/>
                 </a:solidFill>
@@ -7432,7 +6964,7 @@
               </a:spcAft>
             </a:pPr>
             <a:r>
-              <a:rPr sz="1600" b="1" i="0">
+              <a:rPr sz="1800" b="1" i="0">
                 <a:solidFill>
                   <a:srgbClr val="0E2746"/>
                 </a:solidFill>
@@ -7448,7 +6980,7 @@
               </a:lnSpc>
             </a:pPr>
             <a:r>
-              <a:rPr sz="1300" b="0" i="0">
+              <a:rPr sz="1500" b="0" i="0">
                 <a:solidFill>
                   <a:srgbClr val="5A6478"/>
                 </a:solidFill>
@@ -7543,7 +7075,7 @@
               </a:spcAft>
             </a:pPr>
             <a:r>
-              <a:rPr sz="1600" b="1" i="0">
+              <a:rPr sz="1800" b="1" i="0">
                 <a:solidFill>
                   <a:srgbClr val="0E2746"/>
                 </a:solidFill>
@@ -7559,7 +7091,7 @@
               </a:lnSpc>
             </a:pPr>
             <a:r>
-              <a:rPr sz="1300" b="0" i="0">
+              <a:rPr sz="1500" b="0" i="0">
                 <a:solidFill>
                   <a:srgbClr val="5A6478"/>
                 </a:solidFill>
@@ -7654,7 +7186,7 @@
               </a:spcAft>
             </a:pPr>
             <a:r>
-              <a:rPr sz="1600" b="1" i="0">
+              <a:rPr sz="1800" b="1" i="0">
                 <a:solidFill>
                   <a:srgbClr val="0E2746"/>
                 </a:solidFill>
@@ -7670,7 +7202,7 @@
               </a:lnSpc>
             </a:pPr>
             <a:r>
-              <a:rPr sz="1300" b="0" i="0">
+              <a:rPr sz="1500" b="0" i="0">
                 <a:solidFill>
                   <a:srgbClr val="5A6478"/>
                 </a:solidFill>
@@ -7765,7 +7297,7 @@
               </a:spcAft>
             </a:pPr>
             <a:r>
-              <a:rPr sz="1600" b="1" i="0">
+              <a:rPr sz="1800" b="1" i="0">
                 <a:solidFill>
                   <a:srgbClr val="0E2746"/>
                 </a:solidFill>
@@ -7781,91 +7313,13 @@
               </a:lnSpc>
             </a:pPr>
             <a:r>
-              <a:rPr sz="1300" b="0" i="0">
+              <a:rPr sz="1500" b="0" i="0">
                 <a:solidFill>
                   <a:srgbClr val="5A6478"/>
                 </a:solidFill>
                 <a:latin typeface="Alegreya Sans"/>
               </a:rPr>
               <a:t>No guesswork, no extremes — just a clear plan that fits your life.</a:t>
-            </a:r>
-          </a:p>
-        </p:txBody>
-      </p:sp>
-      <p:sp>
-        <p:nvSpPr>
-          <p:cNvPr id="22" name="TextBox 21"/>
-          <p:cNvSpPr txBox="1"/>
-          <p:nvPr/>
-        </p:nvSpPr>
-        <p:spPr>
-          <a:xfrm>
-            <a:off x="640080" y="6382512"/>
-            <a:ext cx="7315200" cy="365760"/>
-          </a:xfrm>
-          <a:prstGeom prst="rect">
-            <a:avLst/>
-          </a:prstGeom>
-          <a:noFill/>
-        </p:spPr>
-        <p:txBody>
-          <a:bodyPr wrap="square" lIns="0" rIns="0" tIns="0" bIns="0" anchor="t">
-            <a:spAutoFit/>
-          </a:bodyPr>
-          <a:lstStyle/>
-          <a:p>
-            <a:pPr algn="l">
-              <a:lnSpc>
-                <a:spcPct val="120000"/>
-              </a:lnSpc>
-            </a:pPr>
-            <a:r>
-              <a:rPr sz="1250" b="0" i="1">
-                <a:solidFill>
-                  <a:srgbClr val="5A6478"/>
-                </a:solidFill>
-                <a:latin typeface="Libre Baskerville"/>
-              </a:rPr>
-              <a:t>The Weight Loss Academy</a:t>
-            </a:r>
-          </a:p>
-        </p:txBody>
-      </p:sp>
-      <p:sp>
-        <p:nvSpPr>
-          <p:cNvPr id="23" name="TextBox 22"/>
-          <p:cNvSpPr txBox="1"/>
-          <p:nvPr/>
-        </p:nvSpPr>
-        <p:spPr>
-          <a:xfrm>
-            <a:off x="6949440" y="6382512"/>
-            <a:ext cx="4572000" cy="365760"/>
-          </a:xfrm>
-          <a:prstGeom prst="rect">
-            <a:avLst/>
-          </a:prstGeom>
-          <a:noFill/>
-        </p:spPr>
-        <p:txBody>
-          <a:bodyPr wrap="square" lIns="0" rIns="0" tIns="0" bIns="0" anchor="t">
-            <a:spAutoFit/>
-          </a:bodyPr>
-          <a:lstStyle/>
-          <a:p>
-            <a:pPr algn="r">
-              <a:lnSpc>
-                <a:spcPct val="120000"/>
-              </a:lnSpc>
-            </a:pPr>
-            <a:r>
-              <a:rPr sz="1100" b="1" i="0" spc="200">
-                <a:solidFill>
-                  <a:srgbClr val="5A6478"/>
-                </a:solidFill>
-                <a:latin typeface="Alegreya Sans"/>
-              </a:rPr>
-              <a:t>VIP 1-2-1 PERSONAL COACHING</a:t>
             </a:r>
           </a:p>
         </p:txBody>
@@ -8103,7 +7557,7 @@
               </a:spcAft>
             </a:pPr>
             <a:r>
-              <a:rPr sz="1900" b="0" i="0">
+              <a:rPr sz="2100" b="0" i="0">
                 <a:solidFill>
                   <a:srgbClr val="333333"/>
                 </a:solidFill>
@@ -8122,7 +7576,7 @@
               </a:spcAft>
             </a:pPr>
             <a:r>
-              <a:rPr sz="1900" b="0" i="0">
+              <a:rPr sz="2100" b="0" i="0">
                 <a:solidFill>
                   <a:srgbClr val="333333"/>
                 </a:solidFill>
@@ -8145,84 +7599,6 @@
                 <a:latin typeface="Libre Baskerville"/>
               </a:rPr>
               <a:t>For this round, I’ve made it far more accessible.</a:t>
-            </a:r>
-          </a:p>
-        </p:txBody>
-      </p:sp>
-      <p:sp>
-        <p:nvSpPr>
-          <p:cNvPr id="7" name="TextBox 6"/>
-          <p:cNvSpPr txBox="1"/>
-          <p:nvPr/>
-        </p:nvSpPr>
-        <p:spPr>
-          <a:xfrm>
-            <a:off x="640080" y="6382512"/>
-            <a:ext cx="7315200" cy="365760"/>
-          </a:xfrm>
-          <a:prstGeom prst="rect">
-            <a:avLst/>
-          </a:prstGeom>
-          <a:noFill/>
-        </p:spPr>
-        <p:txBody>
-          <a:bodyPr wrap="square" lIns="0" rIns="0" tIns="0" bIns="0" anchor="t">
-            <a:spAutoFit/>
-          </a:bodyPr>
-          <a:lstStyle/>
-          <a:p>
-            <a:pPr algn="l">
-              <a:lnSpc>
-                <a:spcPct val="120000"/>
-              </a:lnSpc>
-            </a:pPr>
-            <a:r>
-              <a:rPr sz="1250" b="0" i="1">
-                <a:solidFill>
-                  <a:srgbClr val="5A6478"/>
-                </a:solidFill>
-                <a:latin typeface="Libre Baskerville"/>
-              </a:rPr>
-              <a:t>The Weight Loss Academy</a:t>
-            </a:r>
-          </a:p>
-        </p:txBody>
-      </p:sp>
-      <p:sp>
-        <p:nvSpPr>
-          <p:cNvPr id="8" name="TextBox 7"/>
-          <p:cNvSpPr txBox="1"/>
-          <p:nvPr/>
-        </p:nvSpPr>
-        <p:spPr>
-          <a:xfrm>
-            <a:off x="6949440" y="6382512"/>
-            <a:ext cx="4572000" cy="365760"/>
-          </a:xfrm>
-          <a:prstGeom prst="rect">
-            <a:avLst/>
-          </a:prstGeom>
-          <a:noFill/>
-        </p:spPr>
-        <p:txBody>
-          <a:bodyPr wrap="square" lIns="0" rIns="0" tIns="0" bIns="0" anchor="t">
-            <a:spAutoFit/>
-          </a:bodyPr>
-          <a:lstStyle/>
-          <a:p>
-            <a:pPr algn="r">
-              <a:lnSpc>
-                <a:spcPct val="120000"/>
-              </a:lnSpc>
-            </a:pPr>
-            <a:r>
-              <a:rPr sz="1100" b="1" i="0" spc="200">
-                <a:solidFill>
-                  <a:srgbClr val="5A6478"/>
-                </a:solidFill>
-                <a:latin typeface="Alegreya Sans"/>
-              </a:rPr>
-              <a:t>VIP 1-2-1 PERSONAL COACHING</a:t>
             </a:r>
           </a:p>
         </p:txBody>
@@ -8521,7 +7897,7 @@
               </a:lnSpc>
             </a:pPr>
             <a:r>
-              <a:rPr sz="1500" b="0" i="0">
+              <a:rPr sz="1700" b="0" i="0">
                 <a:solidFill>
                   <a:srgbClr val="333333"/>
                 </a:solidFill>
@@ -8560,7 +7936,7 @@
               </a:lnSpc>
             </a:pPr>
             <a:r>
-              <a:rPr sz="1600" b="0" i="1">
+              <a:rPr sz="1700" b="0" i="1">
                 <a:solidFill>
                   <a:srgbClr val="0E2746"/>
                 </a:solidFill>
@@ -8778,7 +8154,7 @@
               </a:lnSpc>
             </a:pPr>
             <a:r>
-              <a:rPr sz="1500" b="0" i="0">
+              <a:rPr sz="1700" b="0" i="0">
                 <a:solidFill>
                   <a:srgbClr val="F4EBDC"/>
                 </a:solidFill>
@@ -8817,7 +8193,7 @@
               </a:lnSpc>
             </a:pPr>
             <a:r>
-              <a:rPr sz="1600" b="0" i="1">
+              <a:rPr sz="1700" b="0" i="1">
                 <a:solidFill>
                   <a:srgbClr val="FFFFFF"/>
                 </a:solidFill>
@@ -8856,7 +8232,7 @@
               </a:lnSpc>
             </a:pPr>
             <a:r>
-              <a:rPr sz="1300" b="1" i="0" spc="100">
+              <a:rPr sz="1400" b="1" i="0" spc="100">
                 <a:solidFill>
                   <a:srgbClr val="5A6478"/>
                 </a:solidFill>
@@ -9068,7 +8444,7 @@
         </p:nvSpPr>
         <p:spPr>
           <a:xfrm>
-            <a:off x="868680" y="2566035"/>
+            <a:off x="868680" y="2577465"/>
             <a:ext cx="118872" cy="118872"/>
           </a:xfrm>
           <a:prstGeom prst="ellipse">
@@ -9132,7 +8508,7 @@
               </a:lnSpc>
             </a:pPr>
             <a:r>
-              <a:rPr sz="1700" b="0" i="0">
+              <a:rPr sz="1900" b="0" i="0">
                 <a:solidFill>
                   <a:srgbClr val="333333"/>
                 </a:solidFill>
@@ -9151,7 +8527,7 @@
         </p:nvSpPr>
         <p:spPr>
           <a:xfrm>
-            <a:off x="868680" y="3169539"/>
+            <a:off x="868680" y="3180969"/>
             <a:ext cx="118872" cy="118872"/>
           </a:xfrm>
           <a:prstGeom prst="ellipse">
@@ -9215,7 +8591,7 @@
               </a:lnSpc>
             </a:pPr>
             <a:r>
-              <a:rPr sz="1700" b="0" i="0">
+              <a:rPr sz="1900" b="0" i="0">
                 <a:solidFill>
                   <a:srgbClr val="333333"/>
                 </a:solidFill>
@@ -9234,7 +8610,7 @@
         </p:nvSpPr>
         <p:spPr>
           <a:xfrm>
-            <a:off x="868680" y="3773043"/>
+            <a:off x="868680" y="3784473"/>
             <a:ext cx="118872" cy="118872"/>
           </a:xfrm>
           <a:prstGeom prst="ellipse">
@@ -9298,7 +8674,7 @@
               </a:lnSpc>
             </a:pPr>
             <a:r>
-              <a:rPr sz="1700" b="0" i="0">
+              <a:rPr sz="1900" b="0" i="0">
                 <a:solidFill>
                   <a:srgbClr val="333333"/>
                 </a:solidFill>
@@ -9317,7 +8693,7 @@
         </p:nvSpPr>
         <p:spPr>
           <a:xfrm>
-            <a:off x="868680" y="4376547"/>
+            <a:off x="868680" y="4387977"/>
             <a:ext cx="118872" cy="118872"/>
           </a:xfrm>
           <a:prstGeom prst="ellipse">
@@ -9381,7 +8757,7 @@
               </a:lnSpc>
             </a:pPr>
             <a:r>
-              <a:rPr sz="1700" b="0" i="0">
+              <a:rPr sz="1900" b="0" i="0">
                 <a:solidFill>
                   <a:srgbClr val="333333"/>
                 </a:solidFill>
@@ -9400,7 +8776,7 @@
         </p:nvSpPr>
         <p:spPr>
           <a:xfrm>
-            <a:off x="868680" y="4980051"/>
+            <a:off x="868680" y="4991481"/>
             <a:ext cx="118872" cy="118872"/>
           </a:xfrm>
           <a:prstGeom prst="ellipse">
@@ -9464,7 +8840,7 @@
               </a:lnSpc>
             </a:pPr>
             <a:r>
-              <a:rPr sz="1700" b="0" i="0">
+              <a:rPr sz="1900" b="0" i="0">
                 <a:solidFill>
                   <a:srgbClr val="333333"/>
                 </a:solidFill>
@@ -9483,7 +8859,7 @@
         </p:nvSpPr>
         <p:spPr>
           <a:xfrm>
-            <a:off x="868680" y="5583555"/>
+            <a:off x="868680" y="5594985"/>
             <a:ext cx="118872" cy="118872"/>
           </a:xfrm>
           <a:prstGeom prst="ellipse">
@@ -9547,91 +8923,13 @@
               </a:lnSpc>
             </a:pPr>
             <a:r>
-              <a:rPr sz="1700" b="0" i="0">
+              <a:rPr sz="1900" b="0" i="0">
                 <a:solidFill>
                   <a:srgbClr val="333333"/>
                 </a:solidFill>
                 <a:latin typeface="Alegreya Sans"/>
               </a:rPr>
               <a:t>You want to lose up to 3 stone — sustainably, for good</a:t>
-            </a:r>
-          </a:p>
-        </p:txBody>
-      </p:sp>
-      <p:sp>
-        <p:nvSpPr>
-          <p:cNvPr id="18" name="TextBox 17"/>
-          <p:cNvSpPr txBox="1"/>
-          <p:nvPr/>
-        </p:nvSpPr>
-        <p:spPr>
-          <a:xfrm>
-            <a:off x="640080" y="6382512"/>
-            <a:ext cx="7315200" cy="365760"/>
-          </a:xfrm>
-          <a:prstGeom prst="rect">
-            <a:avLst/>
-          </a:prstGeom>
-          <a:noFill/>
-        </p:spPr>
-        <p:txBody>
-          <a:bodyPr wrap="square" lIns="0" rIns="0" tIns="0" bIns="0" anchor="t">
-            <a:spAutoFit/>
-          </a:bodyPr>
-          <a:lstStyle/>
-          <a:p>
-            <a:pPr algn="l">
-              <a:lnSpc>
-                <a:spcPct val="120000"/>
-              </a:lnSpc>
-            </a:pPr>
-            <a:r>
-              <a:rPr sz="1250" b="0" i="1">
-                <a:solidFill>
-                  <a:srgbClr val="5A6478"/>
-                </a:solidFill>
-                <a:latin typeface="Libre Baskerville"/>
-              </a:rPr>
-              <a:t>The Weight Loss Academy</a:t>
-            </a:r>
-          </a:p>
-        </p:txBody>
-      </p:sp>
-      <p:sp>
-        <p:nvSpPr>
-          <p:cNvPr id="19" name="TextBox 18"/>
-          <p:cNvSpPr txBox="1"/>
-          <p:nvPr/>
-        </p:nvSpPr>
-        <p:spPr>
-          <a:xfrm>
-            <a:off x="6949440" y="6382512"/>
-            <a:ext cx="4572000" cy="365760"/>
-          </a:xfrm>
-          <a:prstGeom prst="rect">
-            <a:avLst/>
-          </a:prstGeom>
-          <a:noFill/>
-        </p:spPr>
-        <p:txBody>
-          <a:bodyPr wrap="square" lIns="0" rIns="0" tIns="0" bIns="0" anchor="t">
-            <a:spAutoFit/>
-          </a:bodyPr>
-          <a:lstStyle/>
-          <a:p>
-            <a:pPr algn="r">
-              <a:lnSpc>
-                <a:spcPct val="120000"/>
-              </a:lnSpc>
-            </a:pPr>
-            <a:r>
-              <a:rPr sz="1100" b="1" i="0" spc="200">
-                <a:solidFill>
-                  <a:srgbClr val="5A6478"/>
-                </a:solidFill>
-                <a:latin typeface="Alegreya Sans"/>
-              </a:rPr>
-              <a:t>VIP 1-2-1 PERSONAL COACHING</a:t>
             </a:r>
           </a:p>
         </p:txBody>
@@ -9914,84 +9212,6 @@
           </a:p>
         </p:txBody>
       </p:sp>
-      <p:sp>
-        <p:nvSpPr>
-          <p:cNvPr id="7" name="TextBox 6"/>
-          <p:cNvSpPr txBox="1"/>
-          <p:nvPr/>
-        </p:nvSpPr>
-        <p:spPr>
-          <a:xfrm>
-            <a:off x="640080" y="6382512"/>
-            <a:ext cx="7315200" cy="365760"/>
-          </a:xfrm>
-          <a:prstGeom prst="rect">
-            <a:avLst/>
-          </a:prstGeom>
-          <a:noFill/>
-        </p:spPr>
-        <p:txBody>
-          <a:bodyPr wrap="square" lIns="0" rIns="0" tIns="0" bIns="0" anchor="t">
-            <a:spAutoFit/>
-          </a:bodyPr>
-          <a:lstStyle/>
-          <a:p>
-            <a:pPr algn="l">
-              <a:lnSpc>
-                <a:spcPct val="120000"/>
-              </a:lnSpc>
-            </a:pPr>
-            <a:r>
-              <a:rPr sz="1250" b="0" i="1">
-                <a:solidFill>
-                  <a:srgbClr val="5A6478"/>
-                </a:solidFill>
-                <a:latin typeface="Libre Baskerville"/>
-              </a:rPr>
-              <a:t>The Weight Loss Academy</a:t>
-            </a:r>
-          </a:p>
-        </p:txBody>
-      </p:sp>
-      <p:sp>
-        <p:nvSpPr>
-          <p:cNvPr id="8" name="TextBox 7"/>
-          <p:cNvSpPr txBox="1"/>
-          <p:nvPr/>
-        </p:nvSpPr>
-        <p:spPr>
-          <a:xfrm>
-            <a:off x="6949440" y="6382512"/>
-            <a:ext cx="4572000" cy="365760"/>
-          </a:xfrm>
-          <a:prstGeom prst="rect">
-            <a:avLst/>
-          </a:prstGeom>
-          <a:noFill/>
-        </p:spPr>
-        <p:txBody>
-          <a:bodyPr wrap="square" lIns="0" rIns="0" tIns="0" bIns="0" anchor="t">
-            <a:spAutoFit/>
-          </a:bodyPr>
-          <a:lstStyle/>
-          <a:p>
-            <a:pPr algn="r">
-              <a:lnSpc>
-                <a:spcPct val="120000"/>
-              </a:lnSpc>
-            </a:pPr>
-            <a:r>
-              <a:rPr sz="1100" b="1" i="0" spc="200">
-                <a:solidFill>
-                  <a:srgbClr val="5A6478"/>
-                </a:solidFill>
-                <a:latin typeface="Alegreya Sans"/>
-              </a:rPr>
-              <a:t>VIP 1-2-1 PERSONAL COACHING</a:t>
-            </a:r>
-          </a:p>
-        </p:txBody>
-      </p:sp>
     </p:spTree>
   </p:cSld>
   <p:clrMapOvr>
@@ -10202,7 +9422,7 @@
         </p:nvSpPr>
         <p:spPr>
           <a:xfrm>
-            <a:off x="868680" y="2566035"/>
+            <a:off x="868680" y="2577465"/>
             <a:ext cx="118872" cy="118872"/>
           </a:xfrm>
           <a:prstGeom prst="ellipse">
@@ -10266,7 +9486,7 @@
               </a:lnSpc>
             </a:pPr>
             <a:r>
-              <a:rPr sz="1700" b="0" i="0">
+              <a:rPr sz="1900" b="0" i="0">
                 <a:solidFill>
                   <a:srgbClr val="5A6478"/>
                 </a:solidFill>
@@ -10285,7 +9505,7 @@
         </p:nvSpPr>
         <p:spPr>
           <a:xfrm>
-            <a:off x="868680" y="3169539"/>
+            <a:off x="868680" y="3180969"/>
             <a:ext cx="118872" cy="118872"/>
           </a:xfrm>
           <a:prstGeom prst="ellipse">
@@ -10349,7 +9569,7 @@
               </a:lnSpc>
             </a:pPr>
             <a:r>
-              <a:rPr sz="1700" b="0" i="0">
+              <a:rPr sz="1900" b="0" i="0">
                 <a:solidFill>
                   <a:srgbClr val="5A6478"/>
                 </a:solidFill>
@@ -10368,7 +9588,7 @@
         </p:nvSpPr>
         <p:spPr>
           <a:xfrm>
-            <a:off x="868680" y="3773043"/>
+            <a:off x="868680" y="3784473"/>
             <a:ext cx="118872" cy="118872"/>
           </a:xfrm>
           <a:prstGeom prst="ellipse">
@@ -10432,7 +9652,7 @@
               </a:lnSpc>
             </a:pPr>
             <a:r>
-              <a:rPr sz="1700" b="0" i="0">
+              <a:rPr sz="1900" b="0" i="0">
                 <a:solidFill>
                   <a:srgbClr val="5A6478"/>
                 </a:solidFill>
@@ -10451,7 +9671,7 @@
         </p:nvSpPr>
         <p:spPr>
           <a:xfrm>
-            <a:off x="868680" y="4376547"/>
+            <a:off x="868680" y="4387977"/>
             <a:ext cx="118872" cy="118872"/>
           </a:xfrm>
           <a:prstGeom prst="ellipse">
@@ -10515,7 +9735,7 @@
               </a:lnSpc>
             </a:pPr>
             <a:r>
-              <a:rPr sz="1700" b="0" i="0">
+              <a:rPr sz="1900" b="0" i="0">
                 <a:solidFill>
                   <a:srgbClr val="5A6478"/>
                 </a:solidFill>
@@ -10534,7 +9754,7 @@
         </p:nvSpPr>
         <p:spPr>
           <a:xfrm>
-            <a:off x="868680" y="4980051"/>
+            <a:off x="868680" y="4991481"/>
             <a:ext cx="118872" cy="118872"/>
           </a:xfrm>
           <a:prstGeom prst="ellipse">
@@ -10598,7 +9818,7 @@
               </a:lnSpc>
             </a:pPr>
             <a:r>
-              <a:rPr sz="1700" b="0" i="0">
+              <a:rPr sz="1900" b="0" i="0">
                 <a:solidFill>
                   <a:srgbClr val="5A6478"/>
                 </a:solidFill>
@@ -10617,7 +9837,7 @@
         </p:nvSpPr>
         <p:spPr>
           <a:xfrm>
-            <a:off x="868680" y="5583555"/>
+            <a:off x="868680" y="5594985"/>
             <a:ext cx="118872" cy="118872"/>
           </a:xfrm>
           <a:prstGeom prst="ellipse">
@@ -10681,91 +9901,13 @@
               </a:lnSpc>
             </a:pPr>
             <a:r>
-              <a:rPr sz="1700" b="0" i="0">
+              <a:rPr sz="1900" b="0" i="0">
                 <a:solidFill>
                   <a:srgbClr val="5A6478"/>
                 </a:solidFill>
                 <a:latin typeface="Alegreya Sans"/>
               </a:rPr>
               <a:t>You’re not ready to commit right now</a:t>
-            </a:r>
-          </a:p>
-        </p:txBody>
-      </p:sp>
-      <p:sp>
-        <p:nvSpPr>
-          <p:cNvPr id="18" name="TextBox 17"/>
-          <p:cNvSpPr txBox="1"/>
-          <p:nvPr/>
-        </p:nvSpPr>
-        <p:spPr>
-          <a:xfrm>
-            <a:off x="640080" y="6382512"/>
-            <a:ext cx="7315200" cy="365760"/>
-          </a:xfrm>
-          <a:prstGeom prst="rect">
-            <a:avLst/>
-          </a:prstGeom>
-          <a:noFill/>
-        </p:spPr>
-        <p:txBody>
-          <a:bodyPr wrap="square" lIns="0" rIns="0" tIns="0" bIns="0" anchor="t">
-            <a:spAutoFit/>
-          </a:bodyPr>
-          <a:lstStyle/>
-          <a:p>
-            <a:pPr algn="l">
-              <a:lnSpc>
-                <a:spcPct val="120000"/>
-              </a:lnSpc>
-            </a:pPr>
-            <a:r>
-              <a:rPr sz="1250" b="0" i="1">
-                <a:solidFill>
-                  <a:srgbClr val="5A6478"/>
-                </a:solidFill>
-                <a:latin typeface="Libre Baskerville"/>
-              </a:rPr>
-              <a:t>The Weight Loss Academy</a:t>
-            </a:r>
-          </a:p>
-        </p:txBody>
-      </p:sp>
-      <p:sp>
-        <p:nvSpPr>
-          <p:cNvPr id="19" name="TextBox 18"/>
-          <p:cNvSpPr txBox="1"/>
-          <p:nvPr/>
-        </p:nvSpPr>
-        <p:spPr>
-          <a:xfrm>
-            <a:off x="6949440" y="6382512"/>
-            <a:ext cx="4572000" cy="365760"/>
-          </a:xfrm>
-          <a:prstGeom prst="rect">
-            <a:avLst/>
-          </a:prstGeom>
-          <a:noFill/>
-        </p:spPr>
-        <p:txBody>
-          <a:bodyPr wrap="square" lIns="0" rIns="0" tIns="0" bIns="0" anchor="t">
-            <a:spAutoFit/>
-          </a:bodyPr>
-          <a:lstStyle/>
-          <a:p>
-            <a:pPr algn="r">
-              <a:lnSpc>
-                <a:spcPct val="120000"/>
-              </a:lnSpc>
-            </a:pPr>
-            <a:r>
-              <a:rPr sz="1100" b="1" i="0" spc="200">
-                <a:solidFill>
-                  <a:srgbClr val="5A6478"/>
-                </a:solidFill>
-                <a:latin typeface="Alegreya Sans"/>
-              </a:rPr>
-              <a:t>VIP 1-2-1 PERSONAL COACHING</a:t>
             </a:r>
           </a:p>
         </p:txBody>
@@ -10981,84 +10123,6 @@
           </a:p>
         </p:txBody>
       </p:sp>
-      <p:sp>
-        <p:nvSpPr>
-          <p:cNvPr id="5" name="TextBox 4"/>
-          <p:cNvSpPr txBox="1"/>
-          <p:nvPr/>
-        </p:nvSpPr>
-        <p:spPr>
-          <a:xfrm>
-            <a:off x="640080" y="6382512"/>
-            <a:ext cx="7315200" cy="365760"/>
-          </a:xfrm>
-          <a:prstGeom prst="rect">
-            <a:avLst/>
-          </a:prstGeom>
-          <a:noFill/>
-        </p:spPr>
-        <p:txBody>
-          <a:bodyPr wrap="square" lIns="0" rIns="0" tIns="0" bIns="0" anchor="t">
-            <a:spAutoFit/>
-          </a:bodyPr>
-          <a:lstStyle/>
-          <a:p>
-            <a:pPr algn="l">
-              <a:lnSpc>
-                <a:spcPct val="120000"/>
-              </a:lnSpc>
-            </a:pPr>
-            <a:r>
-              <a:rPr sz="1250" b="0" i="1">
-                <a:solidFill>
-                  <a:srgbClr val="F4EBDC"/>
-                </a:solidFill>
-                <a:latin typeface="Libre Baskerville"/>
-              </a:rPr>
-              <a:t>The Weight Loss Academy</a:t>
-            </a:r>
-          </a:p>
-        </p:txBody>
-      </p:sp>
-      <p:sp>
-        <p:nvSpPr>
-          <p:cNvPr id="6" name="TextBox 5"/>
-          <p:cNvSpPr txBox="1"/>
-          <p:nvPr/>
-        </p:nvSpPr>
-        <p:spPr>
-          <a:xfrm>
-            <a:off x="6949440" y="6382512"/>
-            <a:ext cx="4572000" cy="365760"/>
-          </a:xfrm>
-          <a:prstGeom prst="rect">
-            <a:avLst/>
-          </a:prstGeom>
-          <a:noFill/>
-        </p:spPr>
-        <p:txBody>
-          <a:bodyPr wrap="square" lIns="0" rIns="0" tIns="0" bIns="0" anchor="t">
-            <a:spAutoFit/>
-          </a:bodyPr>
-          <a:lstStyle/>
-          <a:p>
-            <a:pPr algn="r">
-              <a:lnSpc>
-                <a:spcPct val="120000"/>
-              </a:lnSpc>
-            </a:pPr>
-            <a:r>
-              <a:rPr sz="1100" b="1" i="0" spc="200">
-                <a:solidFill>
-                  <a:srgbClr val="F4EBDC"/>
-                </a:solidFill>
-                <a:latin typeface="Alegreya Sans"/>
-              </a:rPr>
-              <a:t>VIP 1-2-1 PERSONAL COACHING</a:t>
-            </a:r>
-          </a:p>
-        </p:txBody>
-      </p:sp>
     </p:spTree>
   </p:cSld>
   <p:clrMapOvr>
@@ -11252,7 +10316,7 @@
               </a:lnSpc>
             </a:pPr>
             <a:r>
-              <a:rPr sz="1800" b="0" i="0">
+              <a:rPr sz="2000" b="0" i="0">
                 <a:solidFill>
                   <a:srgbClr val="F4EBDC"/>
                 </a:solidFill>
@@ -11291,7 +10355,7 @@
               </a:lnSpc>
             </a:pPr>
             <a:r>
-              <a:rPr sz="1900" b="1" i="0">
+              <a:rPr sz="2000" b="1" i="0">
                 <a:solidFill>
                   <a:srgbClr val="FFFFFF"/>
                 </a:solidFill>
@@ -11300,7 +10364,7 @@
               <a:t>Email me: </a:t>
             </a:r>
             <a:r>
-              <a:rPr sz="1900" b="1" i="0">
+              <a:rPr sz="2000" b="1" i="0">
                 <a:solidFill>
                   <a:srgbClr val="E5917A"/>
                 </a:solidFill>
@@ -11339,7 +10403,7 @@
               </a:lnSpc>
             </a:pPr>
             <a:r>
-              <a:rPr sz="1800" b="0" i="1">
+              <a:rPr sz="1900" b="0" i="1">
                 <a:solidFill>
                   <a:srgbClr val="FFFFFF"/>
                 </a:solidFill>
@@ -11348,7 +10412,7 @@
               <a:t>Anna Wallace</a:t>
             </a:r>
             <a:r>
-              <a:rPr sz="1400" b="0" i="0">
+              <a:rPr sz="1500" b="0" i="0">
                 <a:solidFill>
                   <a:srgbClr val="F4EBDC"/>
                 </a:solidFill>
@@ -11552,84 +10616,6 @@
           </a:p>
         </p:txBody>
       </p:sp>
-      <p:sp>
-        <p:nvSpPr>
-          <p:cNvPr id="5" name="TextBox 4"/>
-          <p:cNvSpPr txBox="1"/>
-          <p:nvPr/>
-        </p:nvSpPr>
-        <p:spPr>
-          <a:xfrm>
-            <a:off x="640080" y="6382512"/>
-            <a:ext cx="7315200" cy="365760"/>
-          </a:xfrm>
-          <a:prstGeom prst="rect">
-            <a:avLst/>
-          </a:prstGeom>
-          <a:noFill/>
-        </p:spPr>
-        <p:txBody>
-          <a:bodyPr wrap="square" lIns="0" rIns="0" tIns="0" bIns="0" anchor="t">
-            <a:spAutoFit/>
-          </a:bodyPr>
-          <a:lstStyle/>
-          <a:p>
-            <a:pPr algn="l">
-              <a:lnSpc>
-                <a:spcPct val="120000"/>
-              </a:lnSpc>
-            </a:pPr>
-            <a:r>
-              <a:rPr sz="1250" b="0" i="1">
-                <a:solidFill>
-                  <a:srgbClr val="F4EBDC"/>
-                </a:solidFill>
-                <a:latin typeface="Libre Baskerville"/>
-              </a:rPr>
-              <a:t>The Weight Loss Academy</a:t>
-            </a:r>
-          </a:p>
-        </p:txBody>
-      </p:sp>
-      <p:sp>
-        <p:nvSpPr>
-          <p:cNvPr id="6" name="TextBox 5"/>
-          <p:cNvSpPr txBox="1"/>
-          <p:nvPr/>
-        </p:nvSpPr>
-        <p:spPr>
-          <a:xfrm>
-            <a:off x="6949440" y="6382512"/>
-            <a:ext cx="4572000" cy="365760"/>
-          </a:xfrm>
-          <a:prstGeom prst="rect">
-            <a:avLst/>
-          </a:prstGeom>
-          <a:noFill/>
-        </p:spPr>
-        <p:txBody>
-          <a:bodyPr wrap="square" lIns="0" rIns="0" tIns="0" bIns="0" anchor="t">
-            <a:spAutoFit/>
-          </a:bodyPr>
-          <a:lstStyle/>
-          <a:p>
-            <a:pPr algn="r">
-              <a:lnSpc>
-                <a:spcPct val="120000"/>
-              </a:lnSpc>
-            </a:pPr>
-            <a:r>
-              <a:rPr sz="1100" b="1" i="0" spc="200">
-                <a:solidFill>
-                  <a:srgbClr val="F4EBDC"/>
-                </a:solidFill>
-                <a:latin typeface="Alegreya Sans"/>
-              </a:rPr>
-              <a:t>VIP 1-2-1 PERSONAL COACHING</a:t>
-            </a:r>
-          </a:p>
-        </p:txBody>
-      </p:sp>
     </p:spTree>
   </p:cSld>
   <p:clrMapOvr>
@@ -12330,84 +11316,6 @@
           </a:p>
         </p:txBody>
       </p:sp>
-      <p:sp>
-        <p:nvSpPr>
-          <p:cNvPr id="18" name="TextBox 17"/>
-          <p:cNvSpPr txBox="1"/>
-          <p:nvPr/>
-        </p:nvSpPr>
-        <p:spPr>
-          <a:xfrm>
-            <a:off x="640080" y="6382512"/>
-            <a:ext cx="7315200" cy="365760"/>
-          </a:xfrm>
-          <a:prstGeom prst="rect">
-            <a:avLst/>
-          </a:prstGeom>
-          <a:noFill/>
-        </p:spPr>
-        <p:txBody>
-          <a:bodyPr wrap="square" lIns="0" rIns="0" tIns="0" bIns="0" anchor="t">
-            <a:spAutoFit/>
-          </a:bodyPr>
-          <a:lstStyle/>
-          <a:p>
-            <a:pPr algn="l">
-              <a:lnSpc>
-                <a:spcPct val="120000"/>
-              </a:lnSpc>
-            </a:pPr>
-            <a:r>
-              <a:rPr sz="1250" b="0" i="1">
-                <a:solidFill>
-                  <a:srgbClr val="5A6478"/>
-                </a:solidFill>
-                <a:latin typeface="Libre Baskerville"/>
-              </a:rPr>
-              <a:t>The Weight Loss Academy</a:t>
-            </a:r>
-          </a:p>
-        </p:txBody>
-      </p:sp>
-      <p:sp>
-        <p:nvSpPr>
-          <p:cNvPr id="19" name="TextBox 18"/>
-          <p:cNvSpPr txBox="1"/>
-          <p:nvPr/>
-        </p:nvSpPr>
-        <p:spPr>
-          <a:xfrm>
-            <a:off x="6949440" y="6382512"/>
-            <a:ext cx="4572000" cy="365760"/>
-          </a:xfrm>
-          <a:prstGeom prst="rect">
-            <a:avLst/>
-          </a:prstGeom>
-          <a:noFill/>
-        </p:spPr>
-        <p:txBody>
-          <a:bodyPr wrap="square" lIns="0" rIns="0" tIns="0" bIns="0" anchor="t">
-            <a:spAutoFit/>
-          </a:bodyPr>
-          <a:lstStyle/>
-          <a:p>
-            <a:pPr algn="r">
-              <a:lnSpc>
-                <a:spcPct val="120000"/>
-              </a:lnSpc>
-            </a:pPr>
-            <a:r>
-              <a:rPr sz="1100" b="1" i="0" spc="200">
-                <a:solidFill>
-                  <a:srgbClr val="5A6478"/>
-                </a:solidFill>
-                <a:latin typeface="Alegreya Sans"/>
-              </a:rPr>
-              <a:t>VIP 1-2-1 PERSONAL COACHING</a:t>
-            </a:r>
-          </a:p>
-        </p:txBody>
-      </p:sp>
     </p:spTree>
   </p:cSld>
   <p:clrMapOvr>
@@ -12641,7 +11549,7 @@
               </a:spcAft>
             </a:pPr>
             <a:r>
-              <a:rPr sz="1900" b="0" i="0">
+              <a:rPr sz="2100" b="0" i="0">
                 <a:solidFill>
                   <a:srgbClr val="333333"/>
                 </a:solidFill>
@@ -12657,7 +11565,7 @@
               </a:lnSpc>
             </a:pPr>
             <a:r>
-              <a:rPr sz="1900" b="0" i="0">
+              <a:rPr sz="2100" b="0" i="0">
                 <a:solidFill>
                   <a:srgbClr val="333333"/>
                 </a:solidFill>
@@ -12673,84 +11581,6 @@
                 <a:latin typeface="Libre Baskerville"/>
               </a:rPr>
               <a:t>nothing comes close to personal 1-2-1 coaching.</a:t>
-            </a:r>
-          </a:p>
-        </p:txBody>
-      </p:sp>
-      <p:sp>
-        <p:nvSpPr>
-          <p:cNvPr id="7" name="TextBox 6"/>
-          <p:cNvSpPr txBox="1"/>
-          <p:nvPr/>
-        </p:nvSpPr>
-        <p:spPr>
-          <a:xfrm>
-            <a:off x="640080" y="6382512"/>
-            <a:ext cx="7315200" cy="365760"/>
-          </a:xfrm>
-          <a:prstGeom prst="rect">
-            <a:avLst/>
-          </a:prstGeom>
-          <a:noFill/>
-        </p:spPr>
-        <p:txBody>
-          <a:bodyPr wrap="square" lIns="0" rIns="0" tIns="0" bIns="0" anchor="t">
-            <a:spAutoFit/>
-          </a:bodyPr>
-          <a:lstStyle/>
-          <a:p>
-            <a:pPr algn="l">
-              <a:lnSpc>
-                <a:spcPct val="120000"/>
-              </a:lnSpc>
-            </a:pPr>
-            <a:r>
-              <a:rPr sz="1250" b="0" i="1">
-                <a:solidFill>
-                  <a:srgbClr val="5A6478"/>
-                </a:solidFill>
-                <a:latin typeface="Libre Baskerville"/>
-              </a:rPr>
-              <a:t>The Weight Loss Academy</a:t>
-            </a:r>
-          </a:p>
-        </p:txBody>
-      </p:sp>
-      <p:sp>
-        <p:nvSpPr>
-          <p:cNvPr id="8" name="TextBox 7"/>
-          <p:cNvSpPr txBox="1"/>
-          <p:nvPr/>
-        </p:nvSpPr>
-        <p:spPr>
-          <a:xfrm>
-            <a:off x="6949440" y="6382512"/>
-            <a:ext cx="4572000" cy="365760"/>
-          </a:xfrm>
-          <a:prstGeom prst="rect">
-            <a:avLst/>
-          </a:prstGeom>
-          <a:noFill/>
-        </p:spPr>
-        <p:txBody>
-          <a:bodyPr wrap="square" lIns="0" rIns="0" tIns="0" bIns="0" anchor="t">
-            <a:spAutoFit/>
-          </a:bodyPr>
-          <a:lstStyle/>
-          <a:p>
-            <a:pPr algn="r">
-              <a:lnSpc>
-                <a:spcPct val="120000"/>
-              </a:lnSpc>
-            </a:pPr>
-            <a:r>
-              <a:rPr sz="1100" b="1" i="0" spc="200">
-                <a:solidFill>
-                  <a:srgbClr val="5A6478"/>
-                </a:solidFill>
-                <a:latin typeface="Alegreya Sans"/>
-              </a:rPr>
-              <a:t>VIP 1-2-1 PERSONAL COACHING</a:t>
             </a:r>
           </a:p>
         </p:txBody>
@@ -13044,7 +11874,7 @@
               </a:lnSpc>
             </a:pPr>
             <a:r>
-              <a:rPr sz="1800" b="0" i="1">
+              <a:rPr sz="2000" b="0" i="1">
                 <a:solidFill>
                   <a:srgbClr val="FFFFFF"/>
                 </a:solidFill>
@@ -13170,7 +12000,7 @@
               </a:lnSpc>
             </a:pPr>
             <a:r>
-              <a:rPr sz="1800" b="0" i="1">
+              <a:rPr sz="2000" b="0" i="1">
                 <a:solidFill>
                   <a:srgbClr val="FFFFFF"/>
                 </a:solidFill>
@@ -13296,91 +12126,13 @@
               </a:lnSpc>
             </a:pPr>
             <a:r>
-              <a:rPr sz="1800" b="0" i="1">
+              <a:rPr sz="2000" b="0" i="1">
                 <a:solidFill>
                   <a:srgbClr val="FFFFFF"/>
                 </a:solidFill>
                 <a:latin typeface="Libre Baskerville"/>
               </a:rPr>
               <a:t>Results Tracking</a:t>
-            </a:r>
-          </a:p>
-        </p:txBody>
-      </p:sp>
-      <p:sp>
-        <p:nvSpPr>
-          <p:cNvPr id="14" name="TextBox 13"/>
-          <p:cNvSpPr txBox="1"/>
-          <p:nvPr/>
-        </p:nvSpPr>
-        <p:spPr>
-          <a:xfrm>
-            <a:off x="640080" y="6382512"/>
-            <a:ext cx="7315200" cy="365760"/>
-          </a:xfrm>
-          <a:prstGeom prst="rect">
-            <a:avLst/>
-          </a:prstGeom>
-          <a:noFill/>
-        </p:spPr>
-        <p:txBody>
-          <a:bodyPr wrap="square" lIns="0" rIns="0" tIns="0" bIns="0" anchor="t">
-            <a:spAutoFit/>
-          </a:bodyPr>
-          <a:lstStyle/>
-          <a:p>
-            <a:pPr algn="l">
-              <a:lnSpc>
-                <a:spcPct val="120000"/>
-              </a:lnSpc>
-            </a:pPr>
-            <a:r>
-              <a:rPr sz="1250" b="0" i="1">
-                <a:solidFill>
-                  <a:srgbClr val="F4EBDC"/>
-                </a:solidFill>
-                <a:latin typeface="Libre Baskerville"/>
-              </a:rPr>
-              <a:t>The Weight Loss Academy</a:t>
-            </a:r>
-          </a:p>
-        </p:txBody>
-      </p:sp>
-      <p:sp>
-        <p:nvSpPr>
-          <p:cNvPr id="15" name="TextBox 14"/>
-          <p:cNvSpPr txBox="1"/>
-          <p:nvPr/>
-        </p:nvSpPr>
-        <p:spPr>
-          <a:xfrm>
-            <a:off x="6949440" y="6382512"/>
-            <a:ext cx="4572000" cy="365760"/>
-          </a:xfrm>
-          <a:prstGeom prst="rect">
-            <a:avLst/>
-          </a:prstGeom>
-          <a:noFill/>
-        </p:spPr>
-        <p:txBody>
-          <a:bodyPr wrap="square" lIns="0" rIns="0" tIns="0" bIns="0" anchor="t">
-            <a:spAutoFit/>
-          </a:bodyPr>
-          <a:lstStyle/>
-          <a:p>
-            <a:pPr algn="r">
-              <a:lnSpc>
-                <a:spcPct val="120000"/>
-              </a:lnSpc>
-            </a:pPr>
-            <a:r>
-              <a:rPr sz="1100" b="1" i="0" spc="200">
-                <a:solidFill>
-                  <a:srgbClr val="F4EBDC"/>
-                </a:solidFill>
-                <a:latin typeface="Alegreya Sans"/>
-              </a:rPr>
-              <a:t>VIP 1-2-1 PERSONAL COACHING</a:t>
             </a:r>
           </a:p>
         </p:txBody>
@@ -13678,7 +12430,7 @@
               </a:spcAft>
             </a:pPr>
             <a:r>
-              <a:rPr sz="1800" b="0" i="0">
+              <a:rPr sz="2000" b="0" i="0">
                 <a:solidFill>
                   <a:srgbClr val="333333"/>
                 </a:solidFill>
@@ -13697,91 +12449,13 @@
               </a:spcAft>
             </a:pPr>
             <a:r>
-              <a:rPr sz="1800" b="0" i="0">
+              <a:rPr sz="2000" b="0" i="0">
                 <a:solidFill>
                   <a:srgbClr val="333333"/>
                 </a:solidFill>
                 <a:latin typeface="Alegreya Sans"/>
               </a:rPr>
               <a:t>No guesswork. No extremes. No starting again every Monday — just a clear structure that reduces cravings and gets results sooner.</a:t>
-            </a:r>
-          </a:p>
-        </p:txBody>
-      </p:sp>
-      <p:sp>
-        <p:nvSpPr>
-          <p:cNvPr id="9" name="TextBox 8"/>
-          <p:cNvSpPr txBox="1"/>
-          <p:nvPr/>
-        </p:nvSpPr>
-        <p:spPr>
-          <a:xfrm>
-            <a:off x="640080" y="6382512"/>
-            <a:ext cx="7315200" cy="365760"/>
-          </a:xfrm>
-          <a:prstGeom prst="rect">
-            <a:avLst/>
-          </a:prstGeom>
-          <a:noFill/>
-        </p:spPr>
-        <p:txBody>
-          <a:bodyPr wrap="square" lIns="0" rIns="0" tIns="0" bIns="0" anchor="t">
-            <a:spAutoFit/>
-          </a:bodyPr>
-          <a:lstStyle/>
-          <a:p>
-            <a:pPr algn="l">
-              <a:lnSpc>
-                <a:spcPct val="120000"/>
-              </a:lnSpc>
-            </a:pPr>
-            <a:r>
-              <a:rPr sz="1250" b="0" i="1">
-                <a:solidFill>
-                  <a:srgbClr val="5A6478"/>
-                </a:solidFill>
-                <a:latin typeface="Libre Baskerville"/>
-              </a:rPr>
-              <a:t>The Weight Loss Academy</a:t>
-            </a:r>
-          </a:p>
-        </p:txBody>
-      </p:sp>
-      <p:sp>
-        <p:nvSpPr>
-          <p:cNvPr id="10" name="TextBox 9"/>
-          <p:cNvSpPr txBox="1"/>
-          <p:nvPr/>
-        </p:nvSpPr>
-        <p:spPr>
-          <a:xfrm>
-            <a:off x="6949440" y="6382512"/>
-            <a:ext cx="4572000" cy="365760"/>
-          </a:xfrm>
-          <a:prstGeom prst="rect">
-            <a:avLst/>
-          </a:prstGeom>
-          <a:noFill/>
-        </p:spPr>
-        <p:txBody>
-          <a:bodyPr wrap="square" lIns="0" rIns="0" tIns="0" bIns="0" anchor="t">
-            <a:spAutoFit/>
-          </a:bodyPr>
-          <a:lstStyle/>
-          <a:p>
-            <a:pPr algn="r">
-              <a:lnSpc>
-                <a:spcPct val="120000"/>
-              </a:lnSpc>
-            </a:pPr>
-            <a:r>
-              <a:rPr sz="1100" b="1" i="0" spc="200">
-                <a:solidFill>
-                  <a:srgbClr val="5A6478"/>
-                </a:solidFill>
-                <a:latin typeface="Alegreya Sans"/>
-              </a:rPr>
-              <a:t>VIP 1-2-1 PERSONAL COACHING</a:t>
             </a:r>
           </a:p>
         </p:txBody>
@@ -14079,7 +12753,7 @@
               </a:spcAft>
             </a:pPr>
             <a:r>
-              <a:rPr sz="1800" b="0" i="0">
+              <a:rPr sz="2000" b="0" i="0">
                 <a:solidFill>
                   <a:srgbClr val="333333"/>
                 </a:solidFill>
@@ -14098,91 +12772,13 @@
               </a:spcAft>
             </a:pPr>
             <a:r>
-              <a:rPr sz="1800" b="0" i="0">
+              <a:rPr sz="2000" b="0" i="0">
                 <a:solidFill>
                   <a:srgbClr val="333333"/>
                 </a:solidFill>
                 <a:latin typeface="Alegreya Sans"/>
               </a:rPr>
               <a:t>With regular check-ins, coaching and daily support, you stay on track — even on the days you don’t feel like it.</a:t>
-            </a:r>
-          </a:p>
-        </p:txBody>
-      </p:sp>
-      <p:sp>
-        <p:nvSpPr>
-          <p:cNvPr id="9" name="TextBox 8"/>
-          <p:cNvSpPr txBox="1"/>
-          <p:nvPr/>
-        </p:nvSpPr>
-        <p:spPr>
-          <a:xfrm>
-            <a:off x="640080" y="6382512"/>
-            <a:ext cx="7315200" cy="365760"/>
-          </a:xfrm>
-          <a:prstGeom prst="rect">
-            <a:avLst/>
-          </a:prstGeom>
-          <a:noFill/>
-        </p:spPr>
-        <p:txBody>
-          <a:bodyPr wrap="square" lIns="0" rIns="0" tIns="0" bIns="0" anchor="t">
-            <a:spAutoFit/>
-          </a:bodyPr>
-          <a:lstStyle/>
-          <a:p>
-            <a:pPr algn="l">
-              <a:lnSpc>
-                <a:spcPct val="120000"/>
-              </a:lnSpc>
-            </a:pPr>
-            <a:r>
-              <a:rPr sz="1250" b="0" i="1">
-                <a:solidFill>
-                  <a:srgbClr val="5A6478"/>
-                </a:solidFill>
-                <a:latin typeface="Libre Baskerville"/>
-              </a:rPr>
-              <a:t>The Weight Loss Academy</a:t>
-            </a:r>
-          </a:p>
-        </p:txBody>
-      </p:sp>
-      <p:sp>
-        <p:nvSpPr>
-          <p:cNvPr id="10" name="TextBox 9"/>
-          <p:cNvSpPr txBox="1"/>
-          <p:nvPr/>
-        </p:nvSpPr>
-        <p:spPr>
-          <a:xfrm>
-            <a:off x="6949440" y="6382512"/>
-            <a:ext cx="4572000" cy="365760"/>
-          </a:xfrm>
-          <a:prstGeom prst="rect">
-            <a:avLst/>
-          </a:prstGeom>
-          <a:noFill/>
-        </p:spPr>
-        <p:txBody>
-          <a:bodyPr wrap="square" lIns="0" rIns="0" tIns="0" bIns="0" anchor="t">
-            <a:spAutoFit/>
-          </a:bodyPr>
-          <a:lstStyle/>
-          <a:p>
-            <a:pPr algn="r">
-              <a:lnSpc>
-                <a:spcPct val="120000"/>
-              </a:lnSpc>
-            </a:pPr>
-            <a:r>
-              <a:rPr sz="1100" b="1" i="0" spc="200">
-                <a:solidFill>
-                  <a:srgbClr val="5A6478"/>
-                </a:solidFill>
-                <a:latin typeface="Alegreya Sans"/>
-              </a:rPr>
-              <a:t>VIP 1-2-1 PERSONAL COACHING</a:t>
             </a:r>
           </a:p>
         </p:txBody>
@@ -14480,7 +13076,7 @@
               </a:spcAft>
             </a:pPr>
             <a:r>
-              <a:rPr sz="1800" b="0" i="0">
+              <a:rPr sz="2000" b="0" i="0">
                 <a:solidFill>
                   <a:srgbClr val="333333"/>
                 </a:solidFill>
@@ -14499,91 +13095,13 @@
               </a:spcAft>
             </a:pPr>
             <a:r>
-              <a:rPr sz="1800" b="0" i="0">
+              <a:rPr sz="2000" b="0" i="0">
                 <a:solidFill>
                   <a:srgbClr val="333333"/>
                 </a:solidFill>
                 <a:latin typeface="Alegreya Sans"/>
               </a:rPr>
               <a:t>We review everything and make the right adjustments along the way, so your results keep progressing.</a:t>
-            </a:r>
-          </a:p>
-        </p:txBody>
-      </p:sp>
-      <p:sp>
-        <p:nvSpPr>
-          <p:cNvPr id="9" name="TextBox 8"/>
-          <p:cNvSpPr txBox="1"/>
-          <p:nvPr/>
-        </p:nvSpPr>
-        <p:spPr>
-          <a:xfrm>
-            <a:off x="640080" y="6382512"/>
-            <a:ext cx="7315200" cy="365760"/>
-          </a:xfrm>
-          <a:prstGeom prst="rect">
-            <a:avLst/>
-          </a:prstGeom>
-          <a:noFill/>
-        </p:spPr>
-        <p:txBody>
-          <a:bodyPr wrap="square" lIns="0" rIns="0" tIns="0" bIns="0" anchor="t">
-            <a:spAutoFit/>
-          </a:bodyPr>
-          <a:lstStyle/>
-          <a:p>
-            <a:pPr algn="l">
-              <a:lnSpc>
-                <a:spcPct val="120000"/>
-              </a:lnSpc>
-            </a:pPr>
-            <a:r>
-              <a:rPr sz="1250" b="0" i="1">
-                <a:solidFill>
-                  <a:srgbClr val="5A6478"/>
-                </a:solidFill>
-                <a:latin typeface="Libre Baskerville"/>
-              </a:rPr>
-              <a:t>The Weight Loss Academy</a:t>
-            </a:r>
-          </a:p>
-        </p:txBody>
-      </p:sp>
-      <p:sp>
-        <p:nvSpPr>
-          <p:cNvPr id="10" name="TextBox 9"/>
-          <p:cNvSpPr txBox="1"/>
-          <p:nvPr/>
-        </p:nvSpPr>
-        <p:spPr>
-          <a:xfrm>
-            <a:off x="6949440" y="6382512"/>
-            <a:ext cx="4572000" cy="365760"/>
-          </a:xfrm>
-          <a:prstGeom prst="rect">
-            <a:avLst/>
-          </a:prstGeom>
-          <a:noFill/>
-        </p:spPr>
-        <p:txBody>
-          <a:bodyPr wrap="square" lIns="0" rIns="0" tIns="0" bIns="0" anchor="t">
-            <a:spAutoFit/>
-          </a:bodyPr>
-          <a:lstStyle/>
-          <a:p>
-            <a:pPr algn="r">
-              <a:lnSpc>
-                <a:spcPct val="120000"/>
-              </a:lnSpc>
-            </a:pPr>
-            <a:r>
-              <a:rPr sz="1100" b="1" i="0" spc="200">
-                <a:solidFill>
-                  <a:srgbClr val="5A6478"/>
-                </a:solidFill>
-                <a:latin typeface="Alegreya Sans"/>
-              </a:rPr>
-              <a:t>VIP 1-2-1 PERSONAL COACHING</a:t>
             </a:r>
           </a:p>
         </p:txBody>

</xml_diff>

<commit_message>
VIP deck: new hook + larger eyebrows/labels + standout pricing line
- Replace stale 'VIP is back' hook with evergreen 'limited 1-2-1 spots' angle
  (opening + callout slides reworked)
- Bump all eyebrow/section labels and callout pills to 18pt
- Make the pricing payment/availability line 24pt navy so it stands out
</commit_message>
<xml_diff>
--- a/wla-vip-121-deck.pptx
+++ b/wla-vip-121-deck.pptx
@@ -3534,7 +3534,7 @@
               </a:lnSpc>
             </a:pPr>
             <a:r>
-              <a:rPr sz="1600" b="1" i="0" spc="240">
+              <a:rPr sz="1800" b="1" i="0" spc="240">
                 <a:solidFill>
                   <a:srgbClr val="E5917A"/>
                 </a:solidFill>
@@ -3794,7 +3794,7 @@
               </a:lnSpc>
             </a:pPr>
             <a:r>
-              <a:rPr sz="1600" b="1" i="0" spc="240">
+              <a:rPr sz="1800" b="1" i="0" spc="240">
                 <a:solidFill>
                   <a:srgbClr val="D97757"/>
                 </a:solidFill>
@@ -4045,7 +4045,7 @@
               </a:lnSpc>
             </a:pPr>
             <a:r>
-              <a:rPr sz="1600" b="1" i="0" spc="240">
+              <a:rPr sz="1800" b="1" i="0" spc="240">
                 <a:solidFill>
                   <a:srgbClr val="D97757"/>
                 </a:solidFill>
@@ -4745,7 +4745,7 @@
               </a:lnSpc>
             </a:pPr>
             <a:r>
-              <a:rPr sz="1600" b="1" i="0" spc="240">
+              <a:rPr sz="1800" b="1" i="0" spc="240">
                 <a:solidFill>
                   <a:srgbClr val="D97757"/>
                 </a:solidFill>
@@ -5992,7 +5992,7 @@
               </a:lnSpc>
             </a:pPr>
             <a:r>
-              <a:rPr sz="1600" b="1" i="0" spc="240">
+              <a:rPr sz="1800" b="1" i="0" spc="240">
                 <a:solidFill>
                   <a:srgbClr val="E5917A"/>
                 </a:solidFill>
@@ -6333,7 +6333,7 @@
               </a:lnSpc>
             </a:pPr>
             <a:r>
-              <a:rPr sz="1600" b="1" i="0" spc="240">
+              <a:rPr sz="1800" b="1" i="0" spc="240">
                 <a:solidFill>
                   <a:srgbClr val="D97757"/>
                 </a:solidFill>
@@ -7414,7 +7414,7 @@
               </a:lnSpc>
             </a:pPr>
             <a:r>
-              <a:rPr sz="1600" b="1" i="0" spc="240">
+              <a:rPr sz="1800" b="1" i="0" spc="240">
                 <a:solidFill>
                   <a:srgbClr val="D97757"/>
                 </a:solidFill>
@@ -7673,7 +7673,7 @@
         </p:nvSpPr>
         <p:spPr>
           <a:xfrm>
-            <a:off x="822960" y="640080"/>
+            <a:off x="822960" y="566928"/>
             <a:ext cx="10515600" cy="457200"/>
           </a:xfrm>
           <a:prstGeom prst="rect">
@@ -7693,7 +7693,7 @@
               </a:lnSpc>
             </a:pPr>
             <a:r>
-              <a:rPr sz="1500" b="1" i="0" spc="240">
+              <a:rPr sz="1800" b="1" i="0" spc="240">
                 <a:solidFill>
                   <a:srgbClr val="D97757"/>
                 </a:solidFill>
@@ -8212,8 +8212,8 @@
         </p:nvSpPr>
         <p:spPr>
           <a:xfrm>
-            <a:off x="822960" y="5806440"/>
-            <a:ext cx="10515600" cy="457200"/>
+            <a:off x="548640" y="5650992"/>
+            <a:ext cx="11091672" cy="1005840"/>
           </a:xfrm>
           <a:prstGeom prst="rect">
             <a:avLst/>
@@ -8228,13 +8228,13 @@
           <a:p>
             <a:pPr algn="ctr">
               <a:lnSpc>
-                <a:spcPct val="120000"/>
-              </a:lnSpc>
-            </a:pPr>
-            <a:r>
-              <a:rPr sz="1400" b="1" i="0" spc="100">
-                <a:solidFill>
-                  <a:srgbClr val="5A6478"/>
+                <a:spcPct val="125000"/>
+              </a:lnSpc>
+            </a:pPr>
+            <a:r>
+              <a:rPr sz="2400" b="1" i="0" spc="20">
+                <a:solidFill>
+                  <a:srgbClr val="0E2746"/>
                 </a:solidFill>
                 <a:latin typeface="Alegreya Sans"/>
               </a:rPr>
@@ -8333,7 +8333,7 @@
               </a:lnSpc>
             </a:pPr>
             <a:r>
-              <a:rPr sz="1600" b="1" i="0" spc="240">
+              <a:rPr sz="1800" b="1" i="0" spc="240">
                 <a:solidFill>
                   <a:srgbClr val="D97757"/>
                 </a:solidFill>
@@ -9024,13 +9024,13 @@
               </a:lnSpc>
             </a:pPr>
             <a:r>
-              <a:rPr sz="1600" b="1" i="0" spc="240">
+              <a:rPr sz="1800" b="1" i="0" spc="240">
                 <a:solidFill>
                   <a:srgbClr val="D97757"/>
                 </a:solidFill>
                 <a:latin typeface="Alegreya Sans"/>
               </a:rPr>
-              <a:t>BACK BY POPULAR DEMAND</a:t>
+              <a:t>A FEW VIP SPOTS HAVE OPENED</a:t>
             </a:r>
           </a:p>
         </p:txBody>
@@ -9087,7 +9087,7 @@
         </p:nvSpPr>
         <p:spPr>
           <a:xfrm>
-            <a:off x="822960" y="1325880"/>
+            <a:off x="822960" y="1417320"/>
             <a:ext cx="10515600" cy="1828800"/>
           </a:xfrm>
           <a:prstGeom prst="rect">
@@ -9107,31 +9107,49 @@
               </a:lnSpc>
             </a:pPr>
             <a:r>
-              <a:rPr sz="4600" b="1" i="0">
+              <a:rPr sz="3600" b="1" i="0">
                 <a:solidFill>
                   <a:srgbClr val="0E2746"/>
                 </a:solidFill>
                 <a:latin typeface="Libre Baskerville"/>
               </a:rPr>
-              <a:t>VIP is </a:t>
-            </a:r>
-            <a:r>
-              <a:rPr sz="4600" b="1" i="1">
+              <a:t>I only coach a handful of women </a:t>
+            </a:r>
+            <a:r>
+              <a:rPr sz="3600" b="1" i="1">
                 <a:solidFill>
                   <a:srgbClr val="D97757"/>
                 </a:solidFill>
                 <a:latin typeface="Libre Baskerville"/>
               </a:rPr>
-              <a:t>back</a:t>
-            </a:r>
-            <a:r>
-              <a:rPr sz="4600" b="1" i="0">
+              <a:t>1-2-1</a:t>
+            </a:r>
+            <a:r>
+              <a:rPr sz="3600" b="1" i="0">
                 <a:solidFill>
                   <a:srgbClr val="0E2746"/>
                 </a:solidFill>
                 <a:latin typeface="Libre Baskerville"/>
               </a:rPr>
-              <a:t> — and this round, I want to coach you.</a:t>
+              <a:t> at a time — and a few spots have </a:t>
+            </a:r>
+            <a:r>
+              <a:rPr sz="3600" b="1" i="1">
+                <a:solidFill>
+                  <a:srgbClr val="D97757"/>
+                </a:solidFill>
+                <a:latin typeface="Libre Baskerville"/>
+              </a:rPr>
+              <a:t>just opened</a:t>
+            </a:r>
+            <a:r>
+              <a:rPr sz="3600" b="1" i="0">
+                <a:solidFill>
+                  <a:srgbClr val="0E2746"/>
+                </a:solidFill>
+                <a:latin typeface="Libre Baskerville"/>
+              </a:rPr>
+              <a:t>.</a:t>
             </a:r>
           </a:p>
         </p:txBody>
@@ -9144,7 +9162,7 @@
         </p:nvSpPr>
         <p:spPr>
           <a:xfrm>
-            <a:off x="822960" y="3246120"/>
+            <a:off x="822960" y="3383280"/>
             <a:ext cx="10058400" cy="2743200"/>
           </a:xfrm>
           <a:prstGeom prst="rect">
@@ -9167,31 +9185,22 @@
               </a:spcAft>
             </a:pPr>
             <a:r>
-              <a:rPr sz="2000" b="0" i="0">
+              <a:rPr sz="2100" b="0" i="0">
                 <a:solidFill>
                   <a:srgbClr val="333333"/>
                 </a:solidFill>
                 <a:latin typeface="Alegreya Sans"/>
               </a:rPr>
-              <a:t>This round I’m looking for </a:t>
-            </a:r>
-            <a:r>
-              <a:rPr sz="2000" b="1" i="0">
+              <a:t>If you’ve been thinking about going all-in with personal coaching, </a:t>
+            </a:r>
+            <a:r>
+              <a:rPr sz="2100" b="1" i="0">
                 <a:solidFill>
                   <a:srgbClr val="0E2746"/>
                 </a:solidFill>
                 <a:latin typeface="Alegreya Sans"/>
               </a:rPr>
-              <a:t>30 women</a:t>
-            </a:r>
-            <a:r>
-              <a:rPr sz="2000" b="0" i="0">
-                <a:solidFill>
-                  <a:srgbClr val="333333"/>
-                </a:solidFill>
-                <a:latin typeface="Alegreya Sans"/>
-              </a:rPr>
-              <a:t> to coach 1-2-1 — and to create as many success stories as possible.</a:t>
+              <a:t>this is your moment to grab one.</a:t>
             </a:r>
           </a:p>
           <a:p>
@@ -9207,7 +9216,7 @@
                 </a:solidFill>
                 <a:latin typeface="Libre Baskerville"/>
               </a:rPr>
-              <a:t>A brand new round. Risk-free. Built entirely around you.</a:t>
+              <a:t>My full attention, daily support, and a plan built entirely around you.</a:t>
             </a:r>
           </a:p>
         </p:txBody>
@@ -9302,7 +9311,7 @@
               </a:lnSpc>
             </a:pPr>
             <a:r>
-              <a:rPr sz="1600" b="1" i="0" spc="240">
+              <a:rPr sz="1800" b="1" i="0" spc="240">
                 <a:solidFill>
                   <a:srgbClr val="D97757"/>
                 </a:solidFill>
@@ -9982,8 +9991,8 @@
         </p:nvSpPr>
         <p:spPr>
           <a:xfrm>
-            <a:off x="4937760" y="1188720"/>
-            <a:ext cx="2286000" cy="457200"/>
+            <a:off x="4727448" y="1188720"/>
+            <a:ext cx="2743200" cy="457200"/>
           </a:xfrm>
           <a:prstGeom prst="roundRect">
             <a:avLst>
@@ -10018,7 +10027,7 @@
           <a:p>
             <a:pPr algn="ctr"/>
             <a:r>
-              <a:rPr sz="1300" b="1" spc="260">
+              <a:rPr sz="1800" b="1" spc="200">
                 <a:solidFill>
                   <a:srgbClr val="FFFFFF"/>
                 </a:solidFill>
@@ -10193,8 +10202,8 @@
         </p:nvSpPr>
         <p:spPr>
           <a:xfrm>
-            <a:off x="5074920" y="868680"/>
-            <a:ext cx="2011680" cy="457200"/>
+            <a:off x="5047488" y="868680"/>
+            <a:ext cx="2103120" cy="457200"/>
           </a:xfrm>
           <a:prstGeom prst="roundRect">
             <a:avLst>
@@ -10229,7 +10238,7 @@
           <a:p>
             <a:pPr algn="ctr"/>
             <a:r>
-              <a:rPr sz="1300" b="1" spc="300">
+              <a:rPr sz="1800" b="1" spc="250">
                 <a:solidFill>
                   <a:srgbClr val="FFFFFF"/>
                 </a:solidFill>
@@ -10493,8 +10502,8 @@
         </p:nvSpPr>
         <p:spPr>
           <a:xfrm>
-            <a:off x="4178808" y="1371600"/>
-            <a:ext cx="3840480" cy="457200"/>
+            <a:off x="4407408" y="1325880"/>
+            <a:ext cx="3383280" cy="457200"/>
           </a:xfrm>
           <a:prstGeom prst="roundRect">
             <a:avLst>
@@ -10529,13 +10538,13 @@
           <a:p>
             <a:pPr algn="ctr"/>
             <a:r>
-              <a:rPr sz="1300" b="1" spc="160">
+              <a:rPr sz="1800" b="1" spc="200">
                 <a:solidFill>
                   <a:srgbClr val="FFFFFF"/>
                 </a:solidFill>
                 <a:latin typeface="Alegreya Sans"/>
               </a:rPr>
-              <a:t>THE QUESTION I HEAR MOST</a:t>
+              <a:t>WHY VIP WORKS</a:t>
             </a:r>
           </a:p>
         </p:txBody>
@@ -10548,8 +10557,8 @@
         </p:nvSpPr>
         <p:spPr>
           <a:xfrm>
-            <a:off x="1097280" y="2377440"/>
-            <a:ext cx="9966960" cy="2926080"/>
+            <a:off x="1097280" y="2331720"/>
+            <a:ext cx="9966960" cy="2743200"/>
           </a:xfrm>
           <a:prstGeom prst="rect">
             <a:avLst/>
@@ -10564,44 +10573,101 @@
           <a:p>
             <a:pPr algn="ctr">
               <a:lnSpc>
-                <a:spcPct val="112000"/>
+                <a:spcPct val="115000"/>
               </a:lnSpc>
               <a:spcAft>
-                <a:spcPts val="2200"/>
+                <a:spcPts val="1400"/>
               </a:spcAft>
             </a:pPr>
             <a:r>
-              <a:rPr sz="5800" b="0" i="1">
+              <a:rPr sz="4600" b="0" i="1">
                 <a:solidFill>
                   <a:srgbClr val="FFFFFF"/>
                 </a:solidFill>
                 <a:latin typeface="Libre Baskerville"/>
               </a:rPr>
-              <a:t>“When is VIP </a:t>
-            </a:r>
-            <a:r>
-              <a:rPr sz="5800" b="1" i="1">
+              <a:t>The difference isn’t the </a:t>
+            </a:r>
+            <a:r>
+              <a:rPr sz="4600" b="1" i="1">
                 <a:solidFill>
                   <a:srgbClr val="E5917A"/>
                 </a:solidFill>
                 <a:latin typeface="Libre Baskerville"/>
               </a:rPr>
-              <a:t>coming back</a:t>
-            </a:r>
-            <a:r>
-              <a:rPr sz="5800" b="0" i="1">
+              <a:t>plan</a:t>
+            </a:r>
+            <a:r>
+              <a:rPr sz="4600" b="0" i="1">
                 <a:solidFill>
                   <a:srgbClr val="FFFFFF"/>
                 </a:solidFill>
                 <a:latin typeface="Libre Baskerville"/>
               </a:rPr>
-              <a:t>?”</a:t>
+              <a:t>.</a:t>
             </a:r>
           </a:p>
           <a:p>
             <a:pPr algn="ctr">
               <a:lnSpc>
-                <a:spcPct val="140000"/>
+                <a:spcPct val="115000"/>
+              </a:lnSpc>
+            </a:pPr>
+            <a:r>
+              <a:rPr sz="4600" b="0" i="1">
+                <a:solidFill>
+                  <a:srgbClr val="FFFFFF"/>
+                </a:solidFill>
+                <a:latin typeface="Libre Baskerville"/>
+              </a:rPr>
+              <a:t>It’s having </a:t>
+            </a:r>
+            <a:r>
+              <a:rPr sz="4600" b="1" i="1">
+                <a:solidFill>
+                  <a:srgbClr val="E5917A"/>
+                </a:solidFill>
+                <a:latin typeface="Libre Baskerville"/>
+              </a:rPr>
+              <a:t>me in your corner</a:t>
+            </a:r>
+            <a:r>
+              <a:rPr sz="4600" b="0" i="1">
+                <a:solidFill>
+                  <a:srgbClr val="FFFFFF"/>
+                </a:solidFill>
+                <a:latin typeface="Libre Baskerville"/>
+              </a:rPr>
+              <a:t> — every single day.</a:t>
+            </a:r>
+          </a:p>
+        </p:txBody>
+      </p:sp>
+      <p:sp>
+        <p:nvSpPr>
+          <p:cNvPr id="5" name="TextBox 4"/>
+          <p:cNvSpPr txBox="1"/>
+          <p:nvPr/>
+        </p:nvSpPr>
+        <p:spPr>
+          <a:xfrm>
+            <a:off x="1097280" y="5074920"/>
+            <a:ext cx="9966960" cy="640080"/>
+          </a:xfrm>
+          <a:prstGeom prst="rect">
+            <a:avLst/>
+          </a:prstGeom>
+          <a:noFill/>
+        </p:spPr>
+        <p:txBody>
+          <a:bodyPr wrap="square" lIns="0" rIns="0" tIns="0" bIns="0" anchor="t">
+            <a:spAutoFit/>
+          </a:bodyPr>
+          <a:lstStyle/>
+          <a:p>
+            <a:pPr algn="ctr">
+              <a:lnSpc>
+                <a:spcPct val="120000"/>
               </a:lnSpc>
             </a:pPr>
             <a:r>
@@ -10611,7 +10677,7 @@
                 </a:solidFill>
                 <a:latin typeface="Alegreya Sans"/>
               </a:rPr>
-              <a:t>It’s been closed for over a year. So we’re opening one brand new round of 1-2-1 VIP coaching.</a:t>
+              <a:t>Personalised strategy. Daily support. Real accountability.</a:t>
             </a:r>
           </a:p>
         </p:txBody>
@@ -10706,7 +10772,7 @@
               </a:lnSpc>
             </a:pPr>
             <a:r>
-              <a:rPr sz="1600" b="1" i="0" spc="240">
+              <a:rPr sz="1800" b="1" i="0" spc="240">
                 <a:solidFill>
                   <a:srgbClr val="D97757"/>
                 </a:solidFill>
@@ -11406,7 +11472,7 @@
               </a:lnSpc>
             </a:pPr>
             <a:r>
-              <a:rPr sz="1600" b="1" i="0" spc="240">
+              <a:rPr sz="1800" b="1" i="0" spc="240">
                 <a:solidFill>
                   <a:srgbClr val="D97757"/>
                 </a:solidFill>
@@ -11655,8 +11721,8 @@
         </p:nvSpPr>
         <p:spPr>
           <a:xfrm>
-            <a:off x="4709160" y="1280160"/>
-            <a:ext cx="2743200" cy="457200"/>
+            <a:off x="4498848" y="1280160"/>
+            <a:ext cx="3200400" cy="457200"/>
           </a:xfrm>
           <a:prstGeom prst="roundRect">
             <a:avLst>
@@ -11691,7 +11757,7 @@
           <a:p>
             <a:pPr algn="ctr"/>
             <a:r>
-              <a:rPr sz="1300" b="1" spc="260">
+              <a:rPr sz="1800" b="1" spc="200">
                 <a:solidFill>
                   <a:srgbClr val="FFFFFF"/>
                 </a:solidFill>
@@ -12266,7 +12332,7 @@
               </a:lnSpc>
             </a:pPr>
             <a:r>
-              <a:rPr sz="1600" b="1" i="0" spc="240">
+              <a:rPr sz="1800" b="1" i="0" spc="240">
                 <a:solidFill>
                   <a:srgbClr val="D97757"/>
                 </a:solidFill>
@@ -12589,7 +12655,7 @@
               </a:lnSpc>
             </a:pPr>
             <a:r>
-              <a:rPr sz="1600" b="1" i="0" spc="240">
+              <a:rPr sz="1800" b="1" i="0" spc="240">
                 <a:solidFill>
                   <a:srgbClr val="D97757"/>
                 </a:solidFill>
@@ -12912,7 +12978,7 @@
               </a:lnSpc>
             </a:pPr>
             <a:r>
-              <a:rPr sz="1600" b="1" i="0" spc="240">
+              <a:rPr sz="1800" b="1" i="0" spc="240">
                 <a:solidFill>
                   <a:srgbClr val="D97757"/>
                 </a:solidFill>

</xml_diff>